<commit_message>
Dormeo Canada deck: show amounts as $ (cover says CAD)
</commit_message>
<xml_diff>
--- a/dormeo-canada/deck/2026-10-24/Dormeo-Canada-Weekly-Business-Review-Week-43-2026-10-24.pptx
+++ b/dormeo-canada/deck/2026-10-24/Dormeo-Canada-Weekly-Business-Review-Week-43-2026-10-24.pptx
@@ -966,7 +966,7 @@
                 </a:solidFill>
                 <a:latin typeface="Inter"/>
               </a:rPr>
-              <a:t>All amounts in CAD (C$)</a:t>
+              <a:t>All amounts in CAD</a:t>
             </a:r>
           </a:p>
         </p:txBody>
@@ -1589,7 +1589,7 @@
                           </a:solidFill>
                           <a:latin typeface="Inter"/>
                         </a:rPr>
-                        <a:t>C$6,656</a:t>
+                        <a:t>$6,656</a:t>
                       </a:r>
                     </a:p>
                   </a:txBody>
@@ -1612,7 +1612,7 @@
                           </a:solidFill>
                           <a:latin typeface="Inter"/>
                         </a:rPr>
-                        <a:t>C$920</a:t>
+                        <a:t>$920</a:t>
                       </a:r>
                     </a:p>
                   </a:txBody>
@@ -1635,7 +1635,7 @@
                           </a:solidFill>
                           <a:latin typeface="Inter"/>
                         </a:rPr>
-                        <a:t>C$3,607</a:t>
+                        <a:t>$3,607</a:t>
                       </a:r>
                     </a:p>
                   </a:txBody>
@@ -1773,7 +1773,7 @@
                           </a:solidFill>
                           <a:latin typeface="Inter"/>
                         </a:rPr>
-                        <a:t>C$3,049</a:t>
+                        <a:t>$3,049</a:t>
                       </a:r>
                     </a:p>
                   </a:txBody>
@@ -1867,7 +1867,7 @@
                           </a:solidFill>
                           <a:latin typeface="Inter"/>
                         </a:rPr>
-                        <a:t>C$6,329</a:t>
+                        <a:t>$6,329</a:t>
                       </a:r>
                     </a:p>
                   </a:txBody>
@@ -1890,7 +1890,7 @@
                           </a:solidFill>
                           <a:latin typeface="Inter"/>
                         </a:rPr>
-                        <a:t>C$928</a:t>
+                        <a:t>$928</a:t>
                       </a:r>
                     </a:p>
                   </a:txBody>
@@ -1913,7 +1913,7 @@
                           </a:solidFill>
                           <a:latin typeface="Inter"/>
                         </a:rPr>
-                        <a:t>C$3,341</a:t>
+                        <a:t>$3,341</a:t>
                       </a:r>
                     </a:p>
                   </a:txBody>
@@ -2051,7 +2051,7 @@
                           </a:solidFill>
                           <a:latin typeface="Inter"/>
                         </a:rPr>
-                        <a:t>C$2,988</a:t>
+                        <a:t>$2,988</a:t>
                       </a:r>
                     </a:p>
                   </a:txBody>
@@ -2145,7 +2145,7 @@
                           </a:solidFill>
                           <a:latin typeface="Inter"/>
                         </a:rPr>
-                        <a:t>C$4,135</a:t>
+                        <a:t>$4,135</a:t>
                       </a:r>
                     </a:p>
                   </a:txBody>
@@ -2168,7 +2168,7 @@
                           </a:solidFill>
                           <a:latin typeface="Inter"/>
                         </a:rPr>
-                        <a:t>C$704</a:t>
+                        <a:t>$704</a:t>
                       </a:r>
                     </a:p>
                   </a:txBody>
@@ -2191,7 +2191,7 @@
                           </a:solidFill>
                           <a:latin typeface="Inter"/>
                         </a:rPr>
-                        <a:t>C$3,125</a:t>
+                        <a:t>$3,125</a:t>
                       </a:r>
                     </a:p>
                   </a:txBody>
@@ -2329,7 +2329,7 @@
                           </a:solidFill>
                           <a:latin typeface="Inter"/>
                         </a:rPr>
-                        <a:t>C$1,010</a:t>
+                        <a:t>$1,010</a:t>
                       </a:r>
                     </a:p>
                   </a:txBody>
@@ -2423,7 +2423,7 @@
                           </a:solidFill>
                           <a:latin typeface="Inter"/>
                         </a:rPr>
-                        <a:t>C$8,377</a:t>
+                        <a:t>$8,377</a:t>
                       </a:r>
                     </a:p>
                   </a:txBody>
@@ -2446,7 +2446,7 @@
                           </a:solidFill>
                           <a:latin typeface="Inter"/>
                         </a:rPr>
-                        <a:t>C$558</a:t>
+                        <a:t>$558</a:t>
                       </a:r>
                     </a:p>
                   </a:txBody>
@@ -2469,7 +2469,7 @@
                           </a:solidFill>
                           <a:latin typeface="Inter"/>
                         </a:rPr>
-                        <a:t>C$6,124</a:t>
+                        <a:t>$6,124</a:t>
                       </a:r>
                     </a:p>
                   </a:txBody>
@@ -2607,7 +2607,7 @@
                           </a:solidFill>
                           <a:latin typeface="Inter"/>
                         </a:rPr>
-                        <a:t>C$2,253</a:t>
+                        <a:t>$2,253</a:t>
                       </a:r>
                     </a:p>
                   </a:txBody>
@@ -2701,7 +2701,7 @@
                           </a:solidFill>
                           <a:latin typeface="Inter"/>
                         </a:rPr>
-                        <a:t>C$6,160</a:t>
+                        <a:t>$6,160</a:t>
                       </a:r>
                     </a:p>
                   </a:txBody>
@@ -2724,7 +2724,7 @@
                           </a:solidFill>
                           <a:latin typeface="Inter"/>
                         </a:rPr>
-                        <a:t>C$507</a:t>
+                        <a:t>$507</a:t>
                       </a:r>
                     </a:p>
                   </a:txBody>
@@ -2747,7 +2747,7 @@
                           </a:solidFill>
                           <a:latin typeface="Inter"/>
                         </a:rPr>
-                        <a:t>C$3,203</a:t>
+                        <a:t>$3,203</a:t>
                       </a:r>
                     </a:p>
                   </a:txBody>
@@ -2885,7 +2885,7 @@
                           </a:solidFill>
                           <a:latin typeface="Inter"/>
                         </a:rPr>
-                        <a:t>C$2,957</a:t>
+                        <a:t>$2,957</a:t>
                       </a:r>
                     </a:p>
                   </a:txBody>
@@ -2979,7 +2979,7 @@
                           </a:solidFill>
                           <a:latin typeface="Inter"/>
                         </a:rPr>
-                        <a:t>C$3,225</a:t>
+                        <a:t>$3,225</a:t>
                       </a:r>
                     </a:p>
                   </a:txBody>
@@ -3002,7 +3002,7 @@
                           </a:solidFill>
                           <a:latin typeface="Inter"/>
                         </a:rPr>
-                        <a:t>C$577</a:t>
+                        <a:t>$577</a:t>
                       </a:r>
                     </a:p>
                   </a:txBody>
@@ -3025,7 +3025,7 @@
                           </a:solidFill>
                           <a:latin typeface="Inter"/>
                         </a:rPr>
-                        <a:t>C$1,912</a:t>
+                        <a:t>$1,912</a:t>
                       </a:r>
                     </a:p>
                   </a:txBody>
@@ -3163,7 +3163,7 @@
                           </a:solidFill>
                           <a:latin typeface="Inter"/>
                         </a:rPr>
-                        <a:t>C$1,313</a:t>
+                        <a:t>$1,313</a:t>
                       </a:r>
                     </a:p>
                   </a:txBody>
@@ -3257,7 +3257,7 @@
                           </a:solidFill>
                           <a:latin typeface="Inter"/>
                         </a:rPr>
-                        <a:t>C$12,682</a:t>
+                        <a:t>$12,682</a:t>
                       </a:r>
                     </a:p>
                   </a:txBody>
@@ -3280,7 +3280,7 @@
                           </a:solidFill>
                           <a:latin typeface="Inter"/>
                         </a:rPr>
-                        <a:t>C$716</a:t>
+                        <a:t>$716</a:t>
                       </a:r>
                     </a:p>
                   </a:txBody>
@@ -3303,7 +3303,7 @@
                           </a:solidFill>
                           <a:latin typeface="Inter"/>
                         </a:rPr>
-                        <a:t>C$7,800</a:t>
+                        <a:t>$7,800</a:t>
                       </a:r>
                     </a:p>
                   </a:txBody>
@@ -3441,7 +3441,7 @@
                           </a:solidFill>
                           <a:latin typeface="Inter"/>
                         </a:rPr>
-                        <a:t>C$4,882</a:t>
+                        <a:t>$4,882</a:t>
                       </a:r>
                     </a:p>
                   </a:txBody>
@@ -3535,7 +3535,7 @@
                           </a:solidFill>
                           <a:latin typeface="Inter"/>
                         </a:rPr>
-                        <a:t>C$47,564</a:t>
+                        <a:t>$47,564</a:t>
                       </a:r>
                     </a:p>
                   </a:txBody>
@@ -3558,7 +3558,7 @@
                           </a:solidFill>
                           <a:latin typeface="Inter"/>
                         </a:rPr>
-                        <a:t>C$4,911</a:t>
+                        <a:t>$4,911</a:t>
                       </a:r>
                     </a:p>
                   </a:txBody>
@@ -3581,7 +3581,7 @@
                           </a:solidFill>
                           <a:latin typeface="Inter"/>
                         </a:rPr>
-                        <a:t>C$29,112</a:t>
+                        <a:t>$29,112</a:t>
                       </a:r>
                     </a:p>
                   </a:txBody>
@@ -3719,7 +3719,7 @@
                           </a:solidFill>
                           <a:latin typeface="Inter"/>
                         </a:rPr>
-                        <a:t>C$18,452</a:t>
+                        <a:t>$18,452</a:t>
                       </a:r>
                     </a:p>
                   </a:txBody>
@@ -3813,7 +3813,7 @@
                           </a:solidFill>
                           <a:latin typeface="Inter"/>
                         </a:rPr>
-                        <a:t>C$10,572</a:t>
+                        <a:t>$10,572</a:t>
                       </a:r>
                     </a:p>
                   </a:txBody>
@@ -3836,7 +3836,7 @@
                           </a:solidFill>
                           <a:latin typeface="Inter"/>
                         </a:rPr>
-                        <a:t>C$691</a:t>
+                        <a:t>$691</a:t>
                       </a:r>
                     </a:p>
                   </a:txBody>
@@ -3859,7 +3859,7 @@
                           </a:solidFill>
                           <a:latin typeface="Inter"/>
                         </a:rPr>
-                        <a:t>C$6,640</a:t>
+                        <a:t>$6,640</a:t>
                       </a:r>
                     </a:p>
                   </a:txBody>
@@ -3997,7 +3997,7 @@
                           </a:solidFill>
                           <a:latin typeface="Inter"/>
                         </a:rPr>
-                        <a:t>C$3,932</a:t>
+                        <a:t>$3,932</a:t>
                       </a:r>
                     </a:p>
                   </a:txBody>
@@ -4091,7 +4091,7 @@
                           </a:solidFill>
                           <a:latin typeface="Inter"/>
                         </a:rPr>
-                        <a:t>C$7,654</a:t>
+                        <a:t>$7,654</a:t>
                       </a:r>
                     </a:p>
                   </a:txBody>
@@ -4114,7 +4114,7 @@
                           </a:solidFill>
                           <a:latin typeface="Inter"/>
                         </a:rPr>
-                        <a:t>C$474</a:t>
+                        <a:t>$474</a:t>
                       </a:r>
                     </a:p>
                   </a:txBody>
@@ -4137,7 +4137,7 @@
                           </a:solidFill>
                           <a:latin typeface="Inter"/>
                         </a:rPr>
-                        <a:t>C$5,395</a:t>
+                        <a:t>$5,395</a:t>
                       </a:r>
                     </a:p>
                   </a:txBody>
@@ -4275,7 +4275,7 @@
                           </a:solidFill>
                           <a:latin typeface="Inter"/>
                         </a:rPr>
-                        <a:t>C$2,260</a:t>
+                        <a:t>$2,260</a:t>
                       </a:r>
                     </a:p>
                   </a:txBody>
@@ -4369,7 +4369,7 @@
                           </a:solidFill>
                           <a:latin typeface="Inter"/>
                         </a:rPr>
-                        <a:t>C$8,864</a:t>
+                        <a:t>$8,864</a:t>
                       </a:r>
                     </a:p>
                   </a:txBody>
@@ -4392,7 +4392,7 @@
                           </a:solidFill>
                           <a:latin typeface="Inter"/>
                         </a:rPr>
-                        <a:t>C$458</a:t>
+                        <a:t>$458</a:t>
                       </a:r>
                     </a:p>
                   </a:txBody>
@@ -4415,7 +4415,7 @@
                           </a:solidFill>
                           <a:latin typeface="Inter"/>
                         </a:rPr>
-                        <a:t>C$5,446</a:t>
+                        <a:t>$5,446</a:t>
                       </a:r>
                     </a:p>
                   </a:txBody>
@@ -4553,7 +4553,7 @@
                           </a:solidFill>
                           <a:latin typeface="Inter"/>
                         </a:rPr>
-                        <a:t>C$3,418</a:t>
+                        <a:t>$3,418</a:t>
                       </a:r>
                     </a:p>
                   </a:txBody>
@@ -4647,7 +4647,7 @@
                           </a:solidFill>
                           <a:latin typeface="Inter"/>
                         </a:rPr>
-                        <a:t>C$8,931</a:t>
+                        <a:t>$8,931</a:t>
                       </a:r>
                     </a:p>
                   </a:txBody>
@@ -4670,7 +4670,7 @@
                           </a:solidFill>
                           <a:latin typeface="Inter"/>
                         </a:rPr>
-                        <a:t>C$399</a:t>
+                        <a:t>$399</a:t>
                       </a:r>
                     </a:p>
                   </a:txBody>
@@ -4693,7 +4693,7 @@
                           </a:solidFill>
                           <a:latin typeface="Inter"/>
                         </a:rPr>
-                        <a:t>C$3,987</a:t>
+                        <a:t>$3,987</a:t>
                       </a:r>
                     </a:p>
                   </a:txBody>
@@ -4831,7 +4831,7 @@
                           </a:solidFill>
                           <a:latin typeface="Inter"/>
                         </a:rPr>
-                        <a:t>C$4,944</a:t>
+                        <a:t>$4,944</a:t>
                       </a:r>
                     </a:p>
                   </a:txBody>
@@ -4925,7 +4925,7 @@
                           </a:solidFill>
                           <a:latin typeface="Inter"/>
                         </a:rPr>
-                        <a:t>C$4,779</a:t>
+                        <a:t>$4,779</a:t>
                       </a:r>
                     </a:p>
                   </a:txBody>
@@ -4948,7 +4948,7 @@
                           </a:solidFill>
                           <a:latin typeface="Inter"/>
                         </a:rPr>
-                        <a:t>C$503</a:t>
+                        <a:t>$503</a:t>
                       </a:r>
                     </a:p>
                   </a:txBody>
@@ -4971,7 +4971,7 @@
                           </a:solidFill>
                           <a:latin typeface="Inter"/>
                         </a:rPr>
-                        <a:t>C$3,662</a:t>
+                        <a:t>$3,662</a:t>
                       </a:r>
                     </a:p>
                   </a:txBody>
@@ -5109,7 +5109,7 @@
                           </a:solidFill>
                           <a:latin typeface="Inter"/>
                         </a:rPr>
-                        <a:t>C$1,117</a:t>
+                        <a:t>$1,117</a:t>
                       </a:r>
                     </a:p>
                   </a:txBody>
@@ -5203,7 +5203,7 @@
                           </a:solidFill>
                           <a:latin typeface="Inter"/>
                         </a:rPr>
-                        <a:t>C$6,997</a:t>
+                        <a:t>$6,997</a:t>
                       </a:r>
                     </a:p>
                   </a:txBody>
@@ -5226,7 +5226,7 @@
                           </a:solidFill>
                           <a:latin typeface="Inter"/>
                         </a:rPr>
-                        <a:t>C$443</a:t>
+                        <a:t>$443</a:t>
                       </a:r>
                     </a:p>
                   </a:txBody>
@@ -5249,7 +5249,7 @@
                           </a:solidFill>
                           <a:latin typeface="Inter"/>
                         </a:rPr>
-                        <a:t>C$4,588</a:t>
+                        <a:t>$4,588</a:t>
                       </a:r>
                     </a:p>
                   </a:txBody>
@@ -5387,7 +5387,7 @@
                           </a:solidFill>
                           <a:latin typeface="Inter"/>
                         </a:rPr>
-                        <a:t>C$2,410</a:t>
+                        <a:t>$2,410</a:t>
                       </a:r>
                     </a:p>
                   </a:txBody>
@@ -5481,7 +5481,7 @@
                           </a:solidFill>
                           <a:latin typeface="Inter"/>
                         </a:rPr>
-                        <a:t>C$9,865</a:t>
+                        <a:t>$9,865</a:t>
                       </a:r>
                     </a:p>
                   </a:txBody>
@@ -5504,7 +5504,7 @@
                           </a:solidFill>
                           <a:latin typeface="Inter"/>
                         </a:rPr>
-                        <a:t>C$644</a:t>
+                        <a:t>$644</a:t>
                       </a:r>
                     </a:p>
                   </a:txBody>
@@ -5527,7 +5527,7 @@
                           </a:solidFill>
                           <a:latin typeface="Inter"/>
                         </a:rPr>
-                        <a:t>C$4,978</a:t>
+                        <a:t>$4,978</a:t>
                       </a:r>
                     </a:p>
                   </a:txBody>
@@ -5665,7 +5665,7 @@
                           </a:solidFill>
                           <a:latin typeface="Inter"/>
                         </a:rPr>
-                        <a:t>C$4,887</a:t>
+                        <a:t>$4,887</a:t>
                       </a:r>
                     </a:p>
                   </a:txBody>
@@ -5759,7 +5759,7 @@
                           </a:solidFill>
                           <a:latin typeface="Inter"/>
                         </a:rPr>
-                        <a:t>C$57,663</a:t>
+                        <a:t>$57,663</a:t>
                       </a:r>
                     </a:p>
                   </a:txBody>
@@ -5782,7 +5782,7 @@
                           </a:solidFill>
                           <a:latin typeface="Inter"/>
                         </a:rPr>
-                        <a:t>C$3,612</a:t>
+                        <a:t>$3,612</a:t>
                       </a:r>
                     </a:p>
                   </a:txBody>
@@ -5805,7 +5805,7 @@
                           </a:solidFill>
                           <a:latin typeface="Inter"/>
                         </a:rPr>
-                        <a:t>C$34,696</a:t>
+                        <a:t>$34,696</a:t>
                       </a:r>
                     </a:p>
                   </a:txBody>
@@ -5943,7 +5943,7 @@
                           </a:solidFill>
                           <a:latin typeface="Inter"/>
                         </a:rPr>
-                        <a:t>C$22,968</a:t>
+                        <a:t>$22,968</a:t>
                       </a:r>
                     </a:p>
                   </a:txBody>
@@ -6011,7 +6011,7 @@
                 </a:solidFill>
                 <a:latin typeface="Inter"/>
               </a:rPr>
-              <a:t>Organic sales = total sales minus ad-attributed sales (floored at C$0). Daily clicks and impressions aren't in the Sellerise daily feed; weekly totals: 2,521 clicks / 559,135 impressions this week vs 3,202 / 682,497.</a:t>
+              <a:t>Organic sales = total sales minus ad-attributed sales (floored at $0). Daily clicks and impressions aren't in the Sellerise daily feed; weekly totals: 2,521 clicks / 559,135 impressions this week vs 3,202 / 682,497.</a:t>
             </a:r>
           </a:p>
         </p:txBody>
@@ -6550,7 +6550,7 @@
                 </a:solidFill>
                 <a:latin typeface="Inter"/>
               </a:rPr>
-              <a:t>This week: 16 promotion orders, C$82 in promotional discounts (vs C$541 last week).</a:t>
+              <a:t>This week: 16 promotion orders, $82 in promotional discounts (vs $541 last week).</a:t>
             </a:r>
           </a:p>
           <a:p>
@@ -6566,7 +6566,7 @@
                 </a:solidFill>
                 <a:latin typeface="Inter"/>
               </a:rPr>
-              <a:t>October to date: 59 promotion orders, C$4,243 in discounts.</a:t>
+              <a:t>October to date: 59 promotion orders, $4,243 in discounts.</a:t>
             </a:r>
           </a:p>
         </p:txBody>
@@ -10819,7 +10819,7 @@
                           </a:solidFill>
                           <a:latin typeface="Inter"/>
                         </a:rPr>
-                        <a:t>Review the Streaming TV audience campaign: C$1,789 over two weeks with no attributed sales.</a:t>
+                        <a:t>Review the Streaming TV audience campaign: $1,789 over two weeks with no attributed sales.</a:t>
                       </a:r>
                     </a:p>
                   </a:txBody>
@@ -11501,7 +11501,7 @@
                 </a:solidFill>
                 <a:latin typeface="Space Grotesk"/>
               </a:rPr>
-              <a:t>C$3,612</a:t>
+              <a:t>$3,612</a:t>
             </a:r>
           </a:p>
         </p:txBody>
@@ -11536,7 +11536,7 @@
                 </a:solidFill>
                 <a:latin typeface="Inter"/>
               </a:rPr>
-              <a:t>-26% vs C$4,911</a:t>
+              <a:t>-26% vs $4,911</a:t>
             </a:r>
           </a:p>
         </p:txBody>
@@ -11630,7 +11630,7 @@
                 </a:solidFill>
                 <a:latin typeface="Space Grotesk"/>
               </a:rPr>
-              <a:t>C$34,696</a:t>
+              <a:t>$34,696</a:t>
             </a:r>
           </a:p>
         </p:txBody>
@@ -11665,7 +11665,7 @@
                 </a:solidFill>
                 <a:latin typeface="Inter"/>
               </a:rPr>
-              <a:t>+19% vs C$29,112</a:t>
+              <a:t>+19% vs $29,112</a:t>
             </a:r>
           </a:p>
         </p:txBody>
@@ -12015,7 +12015,7 @@
                 </a:solidFill>
                 <a:latin typeface="Inter"/>
               </a:rPr>
-              <a:t>C$4.9K</a:t>
+              <a:t>$4.9K</a:t>
             </a:r>
           </a:p>
         </p:txBody>
@@ -12107,7 +12107,7 @@
                 </a:solidFill>
                 <a:latin typeface="Inter"/>
               </a:rPr>
-              <a:t>C$3.6K</a:t>
+              <a:t>$3.6K</a:t>
             </a:r>
           </a:p>
         </p:txBody>
@@ -12234,7 +12234,7 @@
                 </a:solidFill>
                 <a:latin typeface="Inter"/>
               </a:rPr>
-              <a:t>C$29.1K</a:t>
+              <a:t>$29.1K</a:t>
             </a:r>
           </a:p>
         </p:txBody>
@@ -12326,7 +12326,7 @@
                 </a:solidFill>
                 <a:latin typeface="Inter"/>
               </a:rPr>
-              <a:t>C$34.7K</a:t>
+              <a:t>$34.7K</a:t>
             </a:r>
           </a:p>
         </p:txBody>
@@ -12453,7 +12453,7 @@
                 </a:solidFill>
                 <a:latin typeface="Inter"/>
               </a:rPr>
-              <a:t>C$47.6K</a:t>
+              <a:t>$47.6K</a:t>
             </a:r>
           </a:p>
         </p:txBody>
@@ -12545,7 +12545,7 @@
                 </a:solidFill>
                 <a:latin typeface="Inter"/>
               </a:rPr>
-              <a:t>C$57.7K</a:t>
+              <a:t>$57.7K</a:t>
             </a:r>
           </a:p>
         </p:txBody>
@@ -12992,7 +12992,7 @@
                 </a:solidFill>
                 <a:latin typeface="Space Grotesk"/>
               </a:rPr>
-              <a:t>C$18.4K</a:t>
+              <a:t>$18.4K</a:t>
             </a:r>
           </a:p>
         </p:txBody>
@@ -13086,7 +13086,7 @@
                 </a:solidFill>
                 <a:latin typeface="Space Grotesk"/>
               </a:rPr>
-              <a:t>C$22.8K</a:t>
+              <a:t>$22.8K</a:t>
             </a:r>
           </a:p>
         </p:txBody>
@@ -13374,7 +13374,7 @@
                 </a:solidFill>
                 <a:latin typeface="Inter"/>
               </a:rPr>
-              <a:t>October is 16% behind last year to date and pacing to about C$309.6K (last October: C$350.6K).</a:t>
+              <a:t>October is 16% behind last year to date and pacing to about $309.6K (last October: $350.6K).</a:t>
             </a:r>
           </a:p>
           <a:p>
@@ -13390,7 +13390,7 @@
                 </a:solidFill>
                 <a:latin typeface="Inter"/>
               </a:rPr>
-              <a:t>This week grew 21% to C$57.7K, led by the Queen topper.</a:t>
+              <a:t>This week grew 21% to $57.7K, led by the Queen topper.</a:t>
             </a:r>
           </a:p>
         </p:txBody>
@@ -15188,7 +15188,7 @@
                           </a:solidFill>
                           <a:latin typeface="Inter"/>
                         </a:rPr>
-                        <a:t>C$59,700</a:t>
+                        <a:t>$59,700</a:t>
                       </a:r>
                     </a:p>
                   </a:txBody>
@@ -15234,7 +15234,7 @@
                           </a:solidFill>
                           <a:latin typeface="Inter"/>
                         </a:rPr>
-                        <a:t>C$510</a:t>
+                        <a:t>$510</a:t>
                       </a:r>
                     </a:p>
                   </a:txBody>
@@ -15351,7 +15351,7 @@
                           </a:solidFill>
                           <a:latin typeface="Inter"/>
                         </a:rPr>
-                        <a:t>C$118,943</a:t>
+                        <a:t>$118,943</a:t>
                       </a:r>
                     </a:p>
                   </a:txBody>
@@ -15397,7 +15397,7 @@
                           </a:solidFill>
                           <a:latin typeface="Inter"/>
                         </a:rPr>
-                        <a:t>C$429</a:t>
+                        <a:t>$429</a:t>
                       </a:r>
                     </a:p>
                   </a:txBody>
@@ -15514,7 +15514,7 @@
                           </a:solidFill>
                           <a:latin typeface="Inter"/>
                         </a:rPr>
-                        <a:t>C$47,564</a:t>
+                        <a:t>$47,564</a:t>
                       </a:r>
                     </a:p>
                   </a:txBody>
@@ -15560,7 +15560,7 @@
                           </a:solidFill>
                           <a:latin typeface="Inter"/>
                         </a:rPr>
-                        <a:t>C$410</a:t>
+                        <a:t>$410</a:t>
                       </a:r>
                     </a:p>
                   </a:txBody>
@@ -15677,7 +15677,7 @@
                           </a:solidFill>
                           <a:latin typeface="Inter"/>
                         </a:rPr>
-                        <a:t>C$57,663</a:t>
+                        <a:t>$57,663</a:t>
                       </a:r>
                     </a:p>
                   </a:txBody>
@@ -15723,7 +15723,7 @@
                           </a:solidFill>
                           <a:latin typeface="Inter"/>
                         </a:rPr>
-                        <a:t>C$489</a:t>
+                        <a:t>$489</a:t>
                       </a:r>
                     </a:p>
                   </a:txBody>
@@ -15840,7 +15840,7 @@
                           </a:solidFill>
                           <a:latin typeface="Inter"/>
                         </a:rPr>
-                        <a:t>C$283,870</a:t>
+                        <a:t>$283,870</a:t>
                       </a:r>
                     </a:p>
                   </a:txBody>
@@ -15886,7 +15886,7 @@
                           </a:solidFill>
                           <a:latin typeface="Inter"/>
                         </a:rPr>
-                        <a:t>C$452</a:t>
+                        <a:t>$452</a:t>
                       </a:r>
                     </a:p>
                   </a:txBody>
@@ -16065,7 +16065,7 @@
                 </a:solidFill>
                 <a:latin typeface="Inter"/>
               </a:rPr>
-              <a:t>Sales were C$57,663, +21% vs the prior week (C$47,564), on 118 units (+2%).</a:t>
+              <a:t>Sales were $57,663, +21% vs the prior week ($47,564), on 118 units (+2%).</a:t>
             </a:r>
           </a:p>
           <a:p>
@@ -16539,7 +16539,7 @@
                 </a:solidFill>
                 <a:latin typeface="Space Grotesk"/>
               </a:rPr>
-              <a:t>C$260.5K</a:t>
+              <a:t>$260.5K</a:t>
             </a:r>
           </a:p>
         </p:txBody>
@@ -16668,7 +16668,7 @@
                 </a:solidFill>
                 <a:latin typeface="Space Grotesk"/>
               </a:rPr>
-              <a:t>C$18.4K</a:t>
+              <a:t>$18.4K</a:t>
             </a:r>
           </a:p>
         </p:txBody>
@@ -16961,7 +16961,7 @@
                 </a:solidFill>
                 <a:latin typeface="Inter"/>
               </a:rPr>
-              <a:t>Oct 1–25, 2025: C$310.4K</a:t>
+              <a:t>Oct 1–25, 2025: $310.4K</a:t>
             </a:r>
           </a:p>
         </p:txBody>
@@ -17018,7 +17018,7 @@
                 </a:solidFill>
                 <a:latin typeface="Inter"/>
               </a:rPr>
-              <a:t>C$350.6K</a:t>
+              <a:t>$350.6K</a:t>
             </a:r>
           </a:p>
         </p:txBody>
@@ -17110,7 +17110,7 @@
                 </a:solidFill>
                 <a:latin typeface="Inter"/>
               </a:rPr>
-              <a:t>C$259.4K</a:t>
+              <a:t>$259.4K</a:t>
             </a:r>
           </a:p>
         </p:txBody>
@@ -17202,7 +17202,7 @@
                 </a:solidFill>
                 <a:latin typeface="Inter"/>
               </a:rPr>
-              <a:t>C$260.5K</a:t>
+              <a:t>$260.5K</a:t>
             </a:r>
           </a:p>
         </p:txBody>
@@ -17294,7 +17294,7 @@
                 </a:solidFill>
                 <a:latin typeface="Inter"/>
               </a:rPr>
-              <a:t>C$309.6K</a:t>
+              <a:t>$309.6K</a:t>
             </a:r>
           </a:p>
         </p:txBody>
@@ -17451,7 +17451,7 @@
                 </a:solidFill>
                 <a:latin typeface="Inter"/>
               </a:rPr>
-              <a:t>October is pacing to about C$309.6K: C$260.5K so far plus 6 days at C$8.2K/day (the October daily average without the 2 event days).</a:t>
+              <a:t>October is pacing to about $309.6K: $260.5K so far plus 6 days at $8.2K/day (the October daily average without the 2 event days).</a:t>
             </a:r>
           </a:p>
         </p:txBody>
@@ -17887,7 +17887,7 @@
                 </a:solidFill>
                 <a:latin typeface="Space Grotesk"/>
               </a:rPr>
-              <a:t>C$18.4K</a:t>
+              <a:t>$18.4K</a:t>
             </a:r>
           </a:p>
         </p:txBody>
@@ -17922,7 +17922,7 @@
                 </a:solidFill>
                 <a:latin typeface="Inter"/>
               </a:rPr>
-              <a:t>C$737 per day</a:t>
+              <a:t>$737 per day</a:t>
             </a:r>
           </a:p>
         </p:txBody>
@@ -18016,7 +18016,7 @@
                 </a:solidFill>
                 <a:latin typeface="Space Grotesk"/>
               </a:rPr>
-              <a:t>C$22.8K</a:t>
+              <a:t>$22.8K</a:t>
             </a:r>
           </a:p>
         </p:txBody>
@@ -18409,7 +18409,7 @@
                 </a:solidFill>
                 <a:latin typeface="Inter"/>
               </a:rPr>
-              <a:t>C$168.8K in ad sales on C$18.4K spend, a 9.2x return.</a:t>
+              <a:t>$168.8K in ad sales on $18.4K spend, a 9.2x return.</a:t>
             </a:r>
           </a:p>
           <a:p>
@@ -18641,7 +18641,7 @@
                 </a:solidFill>
                 <a:latin typeface="Inter"/>
               </a:rPr>
-              <a:t>Spend C$3,612 (-26%), ad sales C$34,696 (+19%).</a:t>
+              <a:t>Spend $3,612 (-26%), ad sales $34,696 (+19%).</a:t>
             </a:r>
           </a:p>
           <a:p>
@@ -18673,7 +18673,7 @@
                 </a:solidFill>
                 <a:latin typeface="Inter"/>
               </a:rPr>
-              <a:t>CPC C$1.43, 78 ad orders.</a:t>
+              <a:t>CPC $1.43, 78 ad orders.</a:t>
             </a:r>
           </a:p>
         </p:txBody>
@@ -19129,7 +19129,7 @@
                           </a:solidFill>
                           <a:latin typeface="Inter"/>
                         </a:rPr>
-                        <a:t>C$1,605</a:t>
+                        <a:t>$1,605</a:t>
                       </a:r>
                     </a:p>
                   </a:txBody>
@@ -19152,7 +19152,7 @@
                           </a:solidFill>
                           <a:latin typeface="Inter"/>
                         </a:rPr>
-                        <a:t>C$27,076</a:t>
+                        <a:t>$27,076</a:t>
                       </a:r>
                     </a:p>
                   </a:txBody>
@@ -19269,7 +19269,7 @@
                           </a:solidFill>
                           <a:latin typeface="Inter"/>
                         </a:rPr>
-                        <a:t>C$942</a:t>
+                        <a:t>$942</a:t>
                       </a:r>
                     </a:p>
                   </a:txBody>
@@ -19292,7 +19292,7 @@
                           </a:solidFill>
                           <a:latin typeface="Inter"/>
                         </a:rPr>
-                        <a:t>C$0</a:t>
+                        <a:t>$0</a:t>
                       </a:r>
                     </a:p>
                   </a:txBody>
@@ -19409,7 +19409,7 @@
                           </a:solidFill>
                           <a:latin typeface="Inter"/>
                         </a:rPr>
-                        <a:t>C$568</a:t>
+                        <a:t>$568</a:t>
                       </a:r>
                     </a:p>
                   </a:txBody>
@@ -19432,7 +19432,7 @@
                           </a:solidFill>
                           <a:latin typeface="Inter"/>
                         </a:rPr>
-                        <a:t>C$2,122</a:t>
+                        <a:t>$2,122</a:t>
                       </a:r>
                     </a:p>
                   </a:txBody>
@@ -19549,7 +19549,7 @@
                           </a:solidFill>
                           <a:latin typeface="Inter"/>
                         </a:rPr>
-                        <a:t>C$216</a:t>
+                        <a:t>$216</a:t>
                       </a:r>
                     </a:p>
                   </a:txBody>
@@ -19572,7 +19572,7 @@
                           </a:solidFill>
                           <a:latin typeface="Inter"/>
                         </a:rPr>
-                        <a:t>C$4,301</a:t>
+                        <a:t>$4,301</a:t>
                       </a:r>
                     </a:p>
                   </a:txBody>
@@ -19689,7 +19689,7 @@
                           </a:solidFill>
                           <a:latin typeface="Inter"/>
                         </a:rPr>
-                        <a:t>C$126</a:t>
+                        <a:t>$126</a:t>
                       </a:r>
                     </a:p>
                   </a:txBody>
@@ -19712,7 +19712,7 @@
                           </a:solidFill>
                           <a:latin typeface="Inter"/>
                         </a:rPr>
-                        <a:t>C$735</a:t>
+                        <a:t>$735</a:t>
                       </a:r>
                     </a:p>
                   </a:txBody>
@@ -19829,7 +19829,7 @@
                           </a:solidFill>
                           <a:latin typeface="Inter"/>
                         </a:rPr>
-                        <a:t>C$79</a:t>
+                        <a:t>$79</a:t>
                       </a:r>
                     </a:p>
                   </a:txBody>
@@ -19852,7 +19852,7 @@
                           </a:solidFill>
                           <a:latin typeface="Inter"/>
                         </a:rPr>
-                        <a:t>C$0</a:t>
+                        <a:t>$0</a:t>
                       </a:r>
                     </a:p>
                   </a:txBody>
@@ -19969,7 +19969,7 @@
                           </a:solidFill>
                           <a:latin typeface="Inter"/>
                         </a:rPr>
-                        <a:t>C$55</a:t>
+                        <a:t>$55</a:t>
                       </a:r>
                     </a:p>
                   </a:txBody>
@@ -19992,7 +19992,7 @@
                           </a:solidFill>
                           <a:latin typeface="Inter"/>
                         </a:rPr>
-                        <a:t>C$462</a:t>
+                        <a:t>$462</a:t>
                       </a:r>
                     </a:p>
                   </a:txBody>
@@ -20109,7 +20109,7 @@
                           </a:solidFill>
                           <a:latin typeface="Inter"/>
                         </a:rPr>
-                        <a:t>C$3,602</a:t>
+                        <a:t>$3,602</a:t>
                       </a:r>
                     </a:p>
                   </a:txBody>
@@ -20132,7 +20132,7 @@
                           </a:solidFill>
                           <a:latin typeface="Inter"/>
                         </a:rPr>
-                        <a:t>C$34,696</a:t>
+                        <a:t>$34,696</a:t>
                       </a:r>
                     </a:p>
                   </a:txBody>
@@ -20311,7 +20311,7 @@
                 </a:solidFill>
                 <a:latin typeface="Inter"/>
               </a:rPr>
-              <a:t>Branded keywords brought C$27,076 in sales on C$1,605 spend (5.9% ACoS) and 60 orders.</a:t>
+              <a:t>Branded keywords brought $27,076 in sales on $1,605 spend (5.9% ACoS) and 60 orders.</a:t>
             </a:r>
           </a:p>
           <a:p>
@@ -20327,7 +20327,7 @@
                 </a:solidFill>
                 <a:latin typeface="Inter"/>
               </a:rPr>
-              <a:t>Category keywords spent C$568 for C$2,122 (26.8% ACoS); spend there was cut 55% vs last week.</a:t>
+              <a:t>Category keywords spent $568 for $2,122 (26.8% ACoS); spend there was cut 55% vs last week.</a:t>
             </a:r>
           </a:p>
           <a:p>
@@ -20343,7 +20343,7 @@
                 </a:solidFill>
                 <a:latin typeface="Inter"/>
               </a:rPr>
-              <a:t>Streaming TV spent C$897 this week with no attributed sales.</a:t>
+              <a:t>Streaming TV spent $897 this week with no attributed sales.</a:t>
             </a:r>
           </a:p>
         </p:txBody>
@@ -21525,7 +21525,7 @@
                           </a:solidFill>
                           <a:latin typeface="Inter"/>
                         </a:rPr>
-                        <a:t>C$183</a:t>
+                        <a:t>$183</a:t>
                       </a:r>
                     </a:p>
                   </a:txBody>
@@ -21548,7 +21548,7 @@
                           </a:solidFill>
                           <a:latin typeface="Inter"/>
                         </a:rPr>
-                        <a:t>C$525</a:t>
+                        <a:t>$525</a:t>
                       </a:r>
                     </a:p>
                   </a:txBody>
@@ -21711,7 +21711,7 @@
                           </a:solidFill>
                           <a:latin typeface="Inter"/>
                         </a:rPr>
-                        <a:t>C$76</a:t>
+                        <a:t>$76</a:t>
                       </a:r>
                     </a:p>
                   </a:txBody>
@@ -21734,7 +21734,7 @@
                           </a:solidFill>
                           <a:latin typeface="Inter"/>
                         </a:rPr>
-                        <a:t>C$0</a:t>
+                        <a:t>$0</a:t>
                       </a:r>
                     </a:p>
                   </a:txBody>
@@ -21897,7 +21897,7 @@
                           </a:solidFill>
                           <a:latin typeface="Inter"/>
                         </a:rPr>
-                        <a:t>C$46</a:t>
+                        <a:t>$46</a:t>
                       </a:r>
                     </a:p>
                   </a:txBody>
@@ -21920,7 +21920,7 @@
                           </a:solidFill>
                           <a:latin typeface="Inter"/>
                         </a:rPr>
-                        <a:t>C$0</a:t>
+                        <a:t>$0</a:t>
                       </a:r>
                     </a:p>
                   </a:txBody>
@@ -22083,7 +22083,7 @@
                           </a:solidFill>
                           <a:latin typeface="Inter"/>
                         </a:rPr>
-                        <a:t>C$44</a:t>
+                        <a:t>$44</a:t>
                       </a:r>
                     </a:p>
                   </a:txBody>
@@ -22106,7 +22106,7 @@
                           </a:solidFill>
                           <a:latin typeface="Inter"/>
                         </a:rPr>
-                        <a:t>C$0</a:t>
+                        <a:t>$0</a:t>
                       </a:r>
                     </a:p>
                   </a:txBody>
@@ -22269,7 +22269,7 @@
                           </a:solidFill>
                           <a:latin typeface="Inter"/>
                         </a:rPr>
-                        <a:t>C$40</a:t>
+                        <a:t>$40</a:t>
                       </a:r>
                     </a:p>
                   </a:txBody>
@@ -22292,7 +22292,7 @@
                           </a:solidFill>
                           <a:latin typeface="Inter"/>
                         </a:rPr>
-                        <a:t>C$0</a:t>
+                        <a:t>$0</a:t>
                       </a:r>
                     </a:p>
                   </a:txBody>
@@ -22471,7 +22471,7 @@
                 </a:solidFill>
                 <a:latin typeface="Inter"/>
               </a:rPr>
-              <a:t>Review the Streaming TV audience campaign for the Queen topper: C$897 this week and C$892 last week with no attributed sales.</a:t>
+              <a:t>Review the Streaming TV audience campaign for the Queen topper: $897 this week and $892 last week with no attributed sales.</a:t>
             </a:r>
           </a:p>
           <a:p>
@@ -22487,7 +22487,7 @@
                 </a:solidFill>
                 <a:latin typeface="Inter"/>
               </a:rPr>
-              <a:t>Pause or negate “mattress +topper” (exact, C$76) and “sur matelas dormeo” (exact, C$46): clicks, no sales.</a:t>
+              <a:t>Pause or negate “mattress +topper” (exact, $76) and “sur matelas dormeo” (exact, $46): clicks, no sales.</a:t>
             </a:r>
           </a:p>
           <a:p>
@@ -22503,7 +22503,7 @@
                 </a:solidFill>
                 <a:latin typeface="Inter"/>
               </a:rPr>
-              <a:t>Lower the bid on “mattress +topper” (phrase): C$183 for 1 order.</a:t>
+              <a:t>Lower the bid on “mattress +topper” (phrase): $183 for 1 order.</a:t>
             </a:r>
           </a:p>
           <a:p>
@@ -22861,7 +22861,7 @@
                 </a:solidFill>
                 <a:latin typeface="Space Grotesk"/>
               </a:rPr>
-              <a:t>C$7,047</a:t>
+              <a:t>$7,047</a:t>
             </a:r>
             <a:r>
               <a:rPr sz="1000" b="0">
@@ -22964,7 +22964,7 @@
                 </a:solidFill>
                 <a:latin typeface="Space Grotesk"/>
               </a:rPr>
-              <a:t>C$3,744</a:t>
+              <a:t>$3,744</a:t>
             </a:r>
             <a:r>
               <a:rPr sz="1000" b="0">
@@ -23067,7 +23067,7 @@
                 </a:solidFill>
                 <a:latin typeface="Space Grotesk"/>
               </a:rPr>
-              <a:t>C$2,770</a:t>
+              <a:t>$2,770</a:t>
             </a:r>
             <a:r>
               <a:rPr sz="1000" b="0">
@@ -23170,7 +23170,7 @@
                 </a:solidFill>
                 <a:latin typeface="Space Grotesk"/>
               </a:rPr>
-              <a:t>C$1,199</a:t>
+              <a:t>$1,199</a:t>
             </a:r>
             <a:r>
               <a:rPr sz="1000" b="0">
@@ -23273,7 +23273,7 @@
                 </a:solidFill>
                 <a:latin typeface="Space Grotesk"/>
               </a:rPr>
-              <a:t>C$1,108</a:t>
+              <a:t>$1,108</a:t>
             </a:r>
             <a:r>
               <a:rPr sz="1000" b="0">
@@ -23376,7 +23376,7 @@
                 </a:solidFill>
                 <a:latin typeface="Space Grotesk"/>
               </a:rPr>
-              <a:t>C$953</a:t>
+              <a:t>$953</a:t>
             </a:r>
             <a:r>
               <a:rPr sz="1000" b="0">
@@ -23780,7 +23780,7 @@
                           </a:solidFill>
                           <a:latin typeface="Inter"/>
                         </a:rPr>
-                        <a:t>C$273</a:t>
+                        <a:t>$273</a:t>
                       </a:r>
                     </a:p>
                   </a:txBody>
@@ -23803,7 +23803,7 @@
                           </a:solidFill>
                           <a:latin typeface="Inter"/>
                         </a:rPr>
-                        <a:t>C$7,047</a:t>
+                        <a:t>$7,047</a:t>
                       </a:r>
                     </a:p>
                   </a:txBody>
@@ -23989,7 +23989,7 @@
                           </a:solidFill>
                           <a:latin typeface="Inter"/>
                         </a:rPr>
-                        <a:t>C$94</a:t>
+                        <a:t>$94</a:t>
                       </a:r>
                     </a:p>
                   </a:txBody>
@@ -24012,7 +24012,7 @@
                           </a:solidFill>
                           <a:latin typeface="Inter"/>
                         </a:rPr>
-                        <a:t>C$3,744</a:t>
+                        <a:t>$3,744</a:t>
                       </a:r>
                     </a:p>
                   </a:txBody>
@@ -24198,7 +24198,7 @@
                           </a:solidFill>
                           <a:latin typeface="Inter"/>
                         </a:rPr>
-                        <a:t>C$36</a:t>
+                        <a:t>$36</a:t>
                       </a:r>
                     </a:p>
                   </a:txBody>
@@ -24221,7 +24221,7 @@
                           </a:solidFill>
                           <a:latin typeface="Inter"/>
                         </a:rPr>
-                        <a:t>C$2,770</a:t>
+                        <a:t>$2,770</a:t>
                       </a:r>
                     </a:p>
                   </a:txBody>
@@ -24407,7 +24407,7 @@
                           </a:solidFill>
                           <a:latin typeface="Inter"/>
                         </a:rPr>
-                        <a:t>C$28</a:t>
+                        <a:t>$28</a:t>
                       </a:r>
                     </a:p>
                   </a:txBody>
@@ -24430,7 +24430,7 @@
                           </a:solidFill>
                           <a:latin typeface="Inter"/>
                         </a:rPr>
-                        <a:t>C$1,199</a:t>
+                        <a:t>$1,199</a:t>
                       </a:r>
                     </a:p>
                   </a:txBody>
@@ -24616,7 +24616,7 @@
                           </a:solidFill>
                           <a:latin typeface="Inter"/>
                         </a:rPr>
-                        <a:t>C$24</a:t>
+                        <a:t>$24</a:t>
                       </a:r>
                     </a:p>
                   </a:txBody>
@@ -24639,7 +24639,7 @@
                           </a:solidFill>
                           <a:latin typeface="Inter"/>
                         </a:rPr>
-                        <a:t>C$1,108</a:t>
+                        <a:t>$1,108</a:t>
                       </a:r>
                     </a:p>
                   </a:txBody>
@@ -24825,7 +24825,7 @@
                           </a:solidFill>
                           <a:latin typeface="Inter"/>
                         </a:rPr>
-                        <a:t>C$29</a:t>
+                        <a:t>$29</a:t>
                       </a:r>
                     </a:p>
                   </a:txBody>
@@ -24848,7 +24848,7 @@
                           </a:solidFill>
                           <a:latin typeface="Inter"/>
                         </a:rPr>
-                        <a:t>C$953</a:t>
+                        <a:t>$953</a:t>
                       </a:r>
                     </a:p>
                   </a:txBody>
@@ -25034,7 +25034,7 @@
                           </a:solidFill>
                           <a:latin typeface="Inter"/>
                         </a:rPr>
-                        <a:t>C$254</a:t>
+                        <a:t>$254</a:t>
                       </a:r>
                     </a:p>
                   </a:txBody>
@@ -25057,7 +25057,7 @@
                           </a:solidFill>
                           <a:latin typeface="Inter"/>
                         </a:rPr>
-                        <a:t>C$953</a:t>
+                        <a:t>$953</a:t>
                       </a:r>
                     </a:p>
                   </a:txBody>
@@ -25243,7 +25243,7 @@
                           </a:solidFill>
                           <a:latin typeface="Inter"/>
                         </a:rPr>
-                        <a:t>C$54</a:t>
+                        <a:t>$54</a:t>
                       </a:r>
                     </a:p>
                   </a:txBody>
@@ -25266,7 +25266,7 @@
                           </a:solidFill>
                           <a:latin typeface="Inter"/>
                         </a:rPr>
-                        <a:t>C$694</a:t>
+                        <a:t>$694</a:t>
                       </a:r>
                     </a:p>
                   </a:txBody>
@@ -25871,7 +25871,7 @@
                           </a:solidFill>
                           <a:latin typeface="Inter"/>
                         </a:rPr>
-                        <a:t>C$1</a:t>
+                        <a:t>$1</a:t>
                       </a:r>
                     </a:p>
                   </a:txBody>
@@ -25894,7 +25894,7 @@
                           </a:solidFill>
                           <a:latin typeface="Inter"/>
                         </a:rPr>
-                        <a:t>C$1,079</a:t>
+                        <a:t>$1,079</a:t>
                       </a:r>
                     </a:p>
                   </a:txBody>
@@ -26034,7 +26034,7 @@
                           </a:solidFill>
                           <a:latin typeface="Inter"/>
                         </a:rPr>
-                        <a:t>C$0</a:t>
+                        <a:t>$0</a:t>
                       </a:r>
                     </a:p>
                   </a:txBody>
@@ -26057,7 +26057,7 @@
                           </a:solidFill>
                           <a:latin typeface="Inter"/>
                         </a:rPr>
-                        <a:t>C$554</a:t>
+                        <a:t>$554</a:t>
                       </a:r>
                     </a:p>
                   </a:txBody>
@@ -26197,7 +26197,7 @@
                           </a:solidFill>
                           <a:latin typeface="Inter"/>
                         </a:rPr>
-                        <a:t>C$0</a:t>
+                        <a:t>$0</a:t>
                       </a:r>
                     </a:p>
                   </a:txBody>
@@ -26220,7 +26220,7 @@
                           </a:solidFill>
                           <a:latin typeface="Inter"/>
                         </a:rPr>
-                        <a:t>C$554</a:t>
+                        <a:t>$554</a:t>
                       </a:r>
                     </a:p>
                   </a:txBody>

</xml_diff>

<commit_message>
Weekly decks: fix PowerPoint files so they open in PowerPoint
The build stripped presProps, viewProps and docProps and blanked shape
names to shrink the file for Google Slides; PowerPoint online refuses
that. fix_pptx.py puts them back, build_slides.py now runs it, and both
week 43 decks are repaired.

Co-Authored-By: Claude Opus 5.5 <noreply@anthropic.com>
Claude-Session: https://claude.ai/code/session_01RHhJWYgzkcDa1EG1ieFn7V
</commit_message>
<xml_diff>
--- a/dormeo-canada/deck/2026-10-24/Dormeo-Canada-Weekly-Business-Review-Week-43-2026-10-24.pptx
+++ b/dormeo-canada/deck/2026-10-24/Dormeo-Canada-Weekly-Business-Review-Week-43-2026-10-24.pptx
@@ -723,14 +723,14 @@
   <p:cSld>
     <p:spTree>
       <p:nvGrpSpPr>
-        <p:cNvPr id="1" name=""/>
+        <p:cNvPr id="1" name="Shape 1"/>
         <p:cNvGrpSpPr/>
         <p:nvPr/>
       </p:nvGrpSpPr>
       <p:grpSpPr/>
       <p:sp>
         <p:nvSpPr>
-          <p:cNvPr id="2" name=""/>
+          <p:cNvPr id="2" name="Shape 2"/>
           <p:cNvSpPr/>
           <p:nvPr/>
         </p:nvSpPr>
@@ -752,7 +752,7 @@
       </p:sp>
       <p:sp>
         <p:nvSpPr>
-          <p:cNvPr id="3" name=""/>
+          <p:cNvPr id="3" name="Shape 3"/>
           <p:cNvSpPr/>
           <p:nvPr/>
         </p:nvSpPr>
@@ -774,7 +774,7 @@
       </p:sp>
       <p:pic>
         <p:nvPicPr>
-          <p:cNvPr id="4" name="" descr="logo_dark_s.png"/>
+          <p:cNvPr id="4" name="Shape 4" descr="logo_dark_s.png"/>
           <p:cNvPicPr>
             <a:picLocks noChangeAspect="1"/>
           </p:cNvPicPr>
@@ -798,7 +798,7 @@
       </p:pic>
       <p:sp>
         <p:nvSpPr>
-          <p:cNvPr id="5" name=""/>
+          <p:cNvPr id="5" name="Shape 5"/>
           <p:cNvSpPr txBox="1"/>
           <p:nvPr/>
         </p:nvSpPr>
@@ -833,7 +833,7 @@
       </p:sp>
       <p:sp>
         <p:nvSpPr>
-          <p:cNvPr id="6" name=""/>
+          <p:cNvPr id="6" name="Shape 6"/>
           <p:cNvSpPr txBox="1"/>
           <p:nvPr/>
         </p:nvSpPr>
@@ -868,7 +868,7 @@
       </p:sp>
       <p:sp>
         <p:nvSpPr>
-          <p:cNvPr id="7" name=""/>
+          <p:cNvPr id="7" name="Shape 7"/>
           <p:cNvSpPr txBox="1"/>
           <p:nvPr/>
         </p:nvSpPr>
@@ -903,7 +903,7 @@
       </p:sp>
       <p:sp>
         <p:nvSpPr>
-          <p:cNvPr id="8" name=""/>
+          <p:cNvPr id="8" name="Shape 8"/>
           <p:cNvSpPr txBox="1"/>
           <p:nvPr/>
         </p:nvSpPr>
@@ -938,7 +938,7 @@
       </p:sp>
       <p:sp>
         <p:nvSpPr>
-          <p:cNvPr id="9" name=""/>
+          <p:cNvPr id="9" name="Shape 9"/>
           <p:cNvSpPr txBox="1"/>
           <p:nvPr/>
         </p:nvSpPr>
@@ -984,14 +984,14 @@
   <p:cSld>
     <p:spTree>
       <p:nvGrpSpPr>
-        <p:cNvPr id="1" name=""/>
+        <p:cNvPr id="1" name="Shape 1"/>
         <p:cNvGrpSpPr/>
         <p:nvPr/>
       </p:nvGrpSpPr>
       <p:grpSpPr/>
       <p:sp>
         <p:nvSpPr>
-          <p:cNvPr id="2" name=""/>
+          <p:cNvPr id="2" name="Shape 2"/>
           <p:cNvSpPr/>
           <p:nvPr/>
         </p:nvSpPr>
@@ -1013,7 +1013,7 @@
       </p:sp>
       <p:sp>
         <p:nvSpPr>
-          <p:cNvPr id="3" name=""/>
+          <p:cNvPr id="3" name="Shape 3"/>
           <p:cNvSpPr/>
           <p:nvPr/>
         </p:nvSpPr>
@@ -1035,7 +1035,7 @@
       </p:sp>
       <p:sp>
         <p:nvSpPr>
-          <p:cNvPr id="4" name=""/>
+          <p:cNvPr id="4" name="Shape 4"/>
           <p:cNvSpPr txBox="1"/>
           <p:nvPr/>
         </p:nvSpPr>
@@ -1070,7 +1070,7 @@
       </p:sp>
       <p:sp>
         <p:nvSpPr>
-          <p:cNvPr id="5" name=""/>
+          <p:cNvPr id="5" name="Shape 5"/>
           <p:cNvSpPr txBox="1"/>
           <p:nvPr/>
         </p:nvSpPr>
@@ -1105,7 +1105,7 @@
       </p:sp>
       <p:pic>
         <p:nvPicPr>
-          <p:cNvPr id="6" name="" descr="logo_s.png"/>
+          <p:cNvPr id="6" name="Shape 6" descr="logo_s.png"/>
           <p:cNvPicPr>
             <a:picLocks noChangeAspect="1"/>
           </p:cNvPicPr>
@@ -1129,7 +1129,7 @@
       </p:pic>
       <p:sp>
         <p:nvSpPr>
-          <p:cNvPr id="7" name=""/>
+          <p:cNvPr id="7" name="Shape 7"/>
           <p:cNvSpPr/>
           <p:nvPr/>
         </p:nvSpPr>
@@ -1151,7 +1151,7 @@
       </p:sp>
       <p:sp>
         <p:nvSpPr>
-          <p:cNvPr id="8" name=""/>
+          <p:cNvPr id="8" name="Shape 8"/>
           <p:cNvSpPr txBox="1"/>
           <p:nvPr/>
         </p:nvSpPr>
@@ -1186,7 +1186,7 @@
       </p:sp>
       <p:sp>
         <p:nvSpPr>
-          <p:cNvPr id="9" name=""/>
+          <p:cNvPr id="9" name="Shape 9"/>
           <p:cNvSpPr txBox="1"/>
           <p:nvPr/>
         </p:nvSpPr>
@@ -1221,7 +1221,7 @@
       </p:sp>
       <p:graphicFrame>
         <p:nvGraphicFramePr>
-          <p:cNvPr id="10" name=""/>
+          <p:cNvPr id="10" name="Shape 10"/>
           <p:cNvGraphicFramePr>
             <a:graphicFrameLocks noGrp="1"/>
           </p:cNvGraphicFramePr>
@@ -5983,7 +5983,7 @@
       </p:graphicFrame>
       <p:sp>
         <p:nvSpPr>
-          <p:cNvPr id="11" name=""/>
+          <p:cNvPr id="11" name="Shape 11"/>
           <p:cNvSpPr txBox="1"/>
           <p:nvPr/>
         </p:nvSpPr>
@@ -6029,14 +6029,14 @@
   <p:cSld>
     <p:spTree>
       <p:nvGrpSpPr>
-        <p:cNvPr id="1" name=""/>
+        <p:cNvPr id="1" name="Shape 1"/>
         <p:cNvGrpSpPr/>
         <p:nvPr/>
       </p:nvGrpSpPr>
       <p:grpSpPr/>
       <p:sp>
         <p:nvSpPr>
-          <p:cNvPr id="2" name=""/>
+          <p:cNvPr id="2" name="Shape 2"/>
           <p:cNvSpPr/>
           <p:nvPr/>
         </p:nvSpPr>
@@ -6058,7 +6058,7 @@
       </p:sp>
       <p:sp>
         <p:nvSpPr>
-          <p:cNvPr id="3" name=""/>
+          <p:cNvPr id="3" name="Shape 3"/>
           <p:cNvSpPr/>
           <p:nvPr/>
         </p:nvSpPr>
@@ -6080,7 +6080,7 @@
       </p:sp>
       <p:sp>
         <p:nvSpPr>
-          <p:cNvPr id="4" name=""/>
+          <p:cNvPr id="4" name="Shape 4"/>
           <p:cNvSpPr txBox="1"/>
           <p:nvPr/>
         </p:nvSpPr>
@@ -6115,7 +6115,7 @@
       </p:sp>
       <p:sp>
         <p:nvSpPr>
-          <p:cNvPr id="5" name=""/>
+          <p:cNvPr id="5" name="Shape 5"/>
           <p:cNvSpPr txBox="1"/>
           <p:nvPr/>
         </p:nvSpPr>
@@ -6150,7 +6150,7 @@
       </p:sp>
       <p:pic>
         <p:nvPicPr>
-          <p:cNvPr id="6" name="" descr="logo_s.png"/>
+          <p:cNvPr id="6" name="Shape 6" descr="logo_s.png"/>
           <p:cNvPicPr>
             <a:picLocks noChangeAspect="1"/>
           </p:cNvPicPr>
@@ -6174,7 +6174,7 @@
       </p:pic>
       <p:sp>
         <p:nvSpPr>
-          <p:cNvPr id="7" name=""/>
+          <p:cNvPr id="7" name="Shape 7"/>
           <p:cNvSpPr/>
           <p:nvPr/>
         </p:nvSpPr>
@@ -6196,7 +6196,7 @@
       </p:sp>
       <p:sp>
         <p:nvSpPr>
-          <p:cNvPr id="8" name=""/>
+          <p:cNvPr id="8" name="Shape 8"/>
           <p:cNvSpPr txBox="1"/>
           <p:nvPr/>
         </p:nvSpPr>
@@ -6231,7 +6231,7 @@
       </p:sp>
       <p:sp>
         <p:nvSpPr>
-          <p:cNvPr id="9" name=""/>
+          <p:cNvPr id="9" name="Shape 9"/>
           <p:cNvSpPr txBox="1"/>
           <p:nvPr/>
         </p:nvSpPr>
@@ -6266,7 +6266,7 @@
       </p:sp>
       <p:sp>
         <p:nvSpPr>
-          <p:cNvPr id="10" name=""/>
+          <p:cNvPr id="10" name="Shape 10"/>
           <p:cNvSpPr/>
           <p:nvPr/>
         </p:nvSpPr>
@@ -6290,7 +6290,7 @@
       </p:sp>
       <p:sp>
         <p:nvSpPr>
-          <p:cNvPr id="11" name=""/>
+          <p:cNvPr id="11" name="Shape 11"/>
           <p:cNvSpPr txBox="1"/>
           <p:nvPr/>
         </p:nvSpPr>
@@ -6325,7 +6325,7 @@
       </p:sp>
       <p:sp>
         <p:nvSpPr>
-          <p:cNvPr id="12" name=""/>
+          <p:cNvPr id="12" name="Shape 12"/>
           <p:cNvSpPr/>
           <p:nvPr/>
         </p:nvSpPr>
@@ -6351,7 +6351,7 @@
       </p:sp>
       <p:sp>
         <p:nvSpPr>
-          <p:cNvPr id="13" name=""/>
+          <p:cNvPr id="13" name="Shape 13"/>
           <p:cNvSpPr txBox="1"/>
           <p:nvPr/>
         </p:nvSpPr>
@@ -6386,7 +6386,7 @@
       </p:sp>
       <p:sp>
         <p:nvSpPr>
-          <p:cNvPr id="14" name=""/>
+          <p:cNvPr id="14" name="Shape 14"/>
           <p:cNvSpPr txBox="1"/>
           <p:nvPr/>
         </p:nvSpPr>
@@ -6457,7 +6457,7 @@
       </p:sp>
       <p:sp>
         <p:nvSpPr>
-          <p:cNvPr id="15" name=""/>
+          <p:cNvPr id="15" name="Shape 15"/>
           <p:cNvSpPr/>
           <p:nvPr/>
         </p:nvSpPr>
@@ -6483,7 +6483,7 @@
       </p:sp>
       <p:sp>
         <p:nvSpPr>
-          <p:cNvPr id="16" name=""/>
+          <p:cNvPr id="16" name="Shape 16"/>
           <p:cNvSpPr txBox="1"/>
           <p:nvPr/>
         </p:nvSpPr>
@@ -6518,7 +6518,7 @@
       </p:sp>
       <p:sp>
         <p:nvSpPr>
-          <p:cNvPr id="17" name=""/>
+          <p:cNvPr id="17" name="Shape 17"/>
           <p:cNvSpPr txBox="1"/>
           <p:nvPr/>
         </p:nvSpPr>
@@ -6573,7 +6573,7 @@
       </p:sp>
       <p:sp>
         <p:nvSpPr>
-          <p:cNvPr id="18" name=""/>
+          <p:cNvPr id="18" name="Shape 18"/>
           <p:cNvSpPr/>
           <p:nvPr/>
         </p:nvSpPr>
@@ -6599,7 +6599,7 @@
       </p:sp>
       <p:sp>
         <p:nvSpPr>
-          <p:cNvPr id="19" name=""/>
+          <p:cNvPr id="19" name="Shape 19"/>
           <p:cNvSpPr txBox="1"/>
           <p:nvPr/>
         </p:nvSpPr>
@@ -6634,7 +6634,7 @@
       </p:sp>
       <p:sp>
         <p:nvSpPr>
-          <p:cNvPr id="20" name=""/>
+          <p:cNvPr id="20" name="Shape 20"/>
           <p:cNvSpPr txBox="1"/>
           <p:nvPr/>
         </p:nvSpPr>
@@ -6732,14 +6732,14 @@
   <p:cSld>
     <p:spTree>
       <p:nvGrpSpPr>
-        <p:cNvPr id="1" name=""/>
+        <p:cNvPr id="1" name="Shape 1"/>
         <p:cNvGrpSpPr/>
         <p:nvPr/>
       </p:nvGrpSpPr>
       <p:grpSpPr/>
       <p:sp>
         <p:nvSpPr>
-          <p:cNvPr id="2" name=""/>
+          <p:cNvPr id="2" name="Shape 2"/>
           <p:cNvSpPr/>
           <p:nvPr/>
         </p:nvSpPr>
@@ -6761,7 +6761,7 @@
       </p:sp>
       <p:sp>
         <p:nvSpPr>
-          <p:cNvPr id="3" name=""/>
+          <p:cNvPr id="3" name="Shape 3"/>
           <p:cNvSpPr/>
           <p:nvPr/>
         </p:nvSpPr>
@@ -6783,7 +6783,7 @@
       </p:sp>
       <p:sp>
         <p:nvSpPr>
-          <p:cNvPr id="4" name=""/>
+          <p:cNvPr id="4" name="Shape 4"/>
           <p:cNvSpPr txBox="1"/>
           <p:nvPr/>
         </p:nvSpPr>
@@ -6818,7 +6818,7 @@
       </p:sp>
       <p:sp>
         <p:nvSpPr>
-          <p:cNvPr id="5" name=""/>
+          <p:cNvPr id="5" name="Shape 5"/>
           <p:cNvSpPr txBox="1"/>
           <p:nvPr/>
         </p:nvSpPr>
@@ -6853,7 +6853,7 @@
       </p:sp>
       <p:pic>
         <p:nvPicPr>
-          <p:cNvPr id="6" name="" descr="logo_s.png"/>
+          <p:cNvPr id="6" name="Shape 6" descr="logo_s.png"/>
           <p:cNvPicPr>
             <a:picLocks noChangeAspect="1"/>
           </p:cNvPicPr>
@@ -6877,7 +6877,7 @@
       </p:pic>
       <p:sp>
         <p:nvSpPr>
-          <p:cNvPr id="7" name=""/>
+          <p:cNvPr id="7" name="Shape 7"/>
           <p:cNvSpPr/>
           <p:nvPr/>
         </p:nvSpPr>
@@ -6899,7 +6899,7 @@
       </p:sp>
       <p:sp>
         <p:nvSpPr>
-          <p:cNvPr id="8" name=""/>
+          <p:cNvPr id="8" name="Shape 8"/>
           <p:cNvSpPr txBox="1"/>
           <p:nvPr/>
         </p:nvSpPr>
@@ -6934,7 +6934,7 @@
       </p:sp>
       <p:sp>
         <p:nvSpPr>
-          <p:cNvPr id="9" name=""/>
+          <p:cNvPr id="9" name="Shape 9"/>
           <p:cNvSpPr txBox="1"/>
           <p:nvPr/>
         </p:nvSpPr>
@@ -6969,7 +6969,7 @@
       </p:sp>
       <p:sp>
         <p:nvSpPr>
-          <p:cNvPr id="10" name=""/>
+          <p:cNvPr id="10" name="Shape 10"/>
           <p:cNvSpPr/>
           <p:nvPr/>
         </p:nvSpPr>
@@ -6993,7 +6993,7 @@
       </p:sp>
       <p:sp>
         <p:nvSpPr>
-          <p:cNvPr id="11" name=""/>
+          <p:cNvPr id="11" name="Shape 11"/>
           <p:cNvSpPr txBox="1"/>
           <p:nvPr/>
         </p:nvSpPr>
@@ -7028,7 +7028,7 @@
       </p:sp>
       <p:sp>
         <p:nvSpPr>
-          <p:cNvPr id="12" name=""/>
+          <p:cNvPr id="12" name="Shape 12"/>
           <p:cNvSpPr txBox="1"/>
           <p:nvPr/>
         </p:nvSpPr>
@@ -7063,7 +7063,7 @@
       </p:sp>
       <p:sp>
         <p:nvSpPr>
-          <p:cNvPr id="13" name=""/>
+          <p:cNvPr id="13" name="Shape 13"/>
           <p:cNvSpPr txBox="1"/>
           <p:nvPr/>
         </p:nvSpPr>
@@ -7098,7 +7098,7 @@
       </p:sp>
       <p:sp>
         <p:nvSpPr>
-          <p:cNvPr id="14" name=""/>
+          <p:cNvPr id="14" name="Shape 14"/>
           <p:cNvSpPr/>
           <p:nvPr/>
         </p:nvSpPr>
@@ -7122,7 +7122,7 @@
       </p:sp>
       <p:sp>
         <p:nvSpPr>
-          <p:cNvPr id="15" name=""/>
+          <p:cNvPr id="15" name="Shape 15"/>
           <p:cNvSpPr txBox="1"/>
           <p:nvPr/>
         </p:nvSpPr>
@@ -7157,7 +7157,7 @@
       </p:sp>
       <p:sp>
         <p:nvSpPr>
-          <p:cNvPr id="16" name=""/>
+          <p:cNvPr id="16" name="Shape 16"/>
           <p:cNvSpPr txBox="1"/>
           <p:nvPr/>
         </p:nvSpPr>
@@ -7192,7 +7192,7 @@
       </p:sp>
       <p:sp>
         <p:nvSpPr>
-          <p:cNvPr id="17" name=""/>
+          <p:cNvPr id="17" name="Shape 17"/>
           <p:cNvSpPr txBox="1"/>
           <p:nvPr/>
         </p:nvSpPr>
@@ -7227,7 +7227,7 @@
       </p:sp>
       <p:sp>
         <p:nvSpPr>
-          <p:cNvPr id="18" name=""/>
+          <p:cNvPr id="18" name="Shape 18"/>
           <p:cNvSpPr/>
           <p:nvPr/>
         </p:nvSpPr>
@@ -7251,7 +7251,7 @@
       </p:sp>
       <p:sp>
         <p:nvSpPr>
-          <p:cNvPr id="19" name=""/>
+          <p:cNvPr id="19" name="Shape 19"/>
           <p:cNvSpPr txBox="1"/>
           <p:nvPr/>
         </p:nvSpPr>
@@ -7286,7 +7286,7 @@
       </p:sp>
       <p:sp>
         <p:nvSpPr>
-          <p:cNvPr id="20" name=""/>
+          <p:cNvPr id="20" name="Shape 20"/>
           <p:cNvSpPr txBox="1"/>
           <p:nvPr/>
         </p:nvSpPr>
@@ -7321,7 +7321,7 @@
       </p:sp>
       <p:sp>
         <p:nvSpPr>
-          <p:cNvPr id="21" name=""/>
+          <p:cNvPr id="21" name="Shape 21"/>
           <p:cNvSpPr txBox="1"/>
           <p:nvPr/>
         </p:nvSpPr>
@@ -7356,7 +7356,7 @@
       </p:sp>
       <p:sp>
         <p:nvSpPr>
-          <p:cNvPr id="22" name=""/>
+          <p:cNvPr id="22" name="Shape 22"/>
           <p:cNvSpPr txBox="1"/>
           <p:nvPr/>
         </p:nvSpPr>
@@ -7391,7 +7391,7 @@
       </p:sp>
       <p:sp>
         <p:nvSpPr>
-          <p:cNvPr id="23" name=""/>
+          <p:cNvPr id="23" name="Shape 23"/>
           <p:cNvSpPr txBox="1"/>
           <p:nvPr/>
         </p:nvSpPr>
@@ -7426,7 +7426,7 @@
       </p:sp>
       <p:sp>
         <p:nvSpPr>
-          <p:cNvPr id="24" name=""/>
+          <p:cNvPr id="24" name="Shape 24"/>
           <p:cNvSpPr/>
           <p:nvPr/>
         </p:nvSpPr>
@@ -7448,7 +7448,7 @@
       </p:sp>
       <p:sp>
         <p:nvSpPr>
-          <p:cNvPr id="25" name=""/>
+          <p:cNvPr id="25" name="Shape 25"/>
           <p:cNvSpPr txBox="1"/>
           <p:nvPr/>
         </p:nvSpPr>
@@ -7483,7 +7483,7 @@
       </p:sp>
       <p:sp>
         <p:nvSpPr>
-          <p:cNvPr id="26" name=""/>
+          <p:cNvPr id="26" name="Shape 26"/>
           <p:cNvSpPr txBox="1"/>
           <p:nvPr/>
         </p:nvSpPr>
@@ -7518,7 +7518,7 @@
       </p:sp>
       <p:sp>
         <p:nvSpPr>
-          <p:cNvPr id="27" name=""/>
+          <p:cNvPr id="27" name="Shape 27"/>
           <p:cNvSpPr/>
           <p:nvPr/>
         </p:nvSpPr>
@@ -7540,7 +7540,7 @@
       </p:sp>
       <p:sp>
         <p:nvSpPr>
-          <p:cNvPr id="28" name=""/>
+          <p:cNvPr id="28" name="Shape 28"/>
           <p:cNvSpPr txBox="1"/>
           <p:nvPr/>
         </p:nvSpPr>
@@ -7575,7 +7575,7 @@
       </p:sp>
       <p:sp>
         <p:nvSpPr>
-          <p:cNvPr id="29" name=""/>
+          <p:cNvPr id="29" name="Shape 29"/>
           <p:cNvSpPr txBox="1"/>
           <p:nvPr/>
         </p:nvSpPr>
@@ -7610,7 +7610,7 @@
       </p:sp>
       <p:sp>
         <p:nvSpPr>
-          <p:cNvPr id="30" name=""/>
+          <p:cNvPr id="30" name="Shape 30"/>
           <p:cNvSpPr/>
           <p:nvPr/>
         </p:nvSpPr>
@@ -7632,7 +7632,7 @@
       </p:sp>
       <p:sp>
         <p:nvSpPr>
-          <p:cNvPr id="31" name=""/>
+          <p:cNvPr id="31" name="Shape 31"/>
           <p:cNvSpPr txBox="1"/>
           <p:nvPr/>
         </p:nvSpPr>
@@ -7667,7 +7667,7 @@
       </p:sp>
       <p:sp>
         <p:nvSpPr>
-          <p:cNvPr id="32" name=""/>
+          <p:cNvPr id="32" name="Shape 32"/>
           <p:cNvSpPr txBox="1"/>
           <p:nvPr/>
         </p:nvSpPr>
@@ -7702,7 +7702,7 @@
       </p:sp>
       <p:sp>
         <p:nvSpPr>
-          <p:cNvPr id="33" name=""/>
+          <p:cNvPr id="33" name="Shape 33"/>
           <p:cNvSpPr/>
           <p:nvPr/>
         </p:nvSpPr>
@@ -7724,7 +7724,7 @@
       </p:sp>
       <p:sp>
         <p:nvSpPr>
-          <p:cNvPr id="34" name=""/>
+          <p:cNvPr id="34" name="Shape 34"/>
           <p:cNvSpPr txBox="1"/>
           <p:nvPr/>
         </p:nvSpPr>
@@ -7759,7 +7759,7 @@
       </p:sp>
       <p:sp>
         <p:nvSpPr>
-          <p:cNvPr id="35" name=""/>
+          <p:cNvPr id="35" name="Shape 35"/>
           <p:cNvSpPr txBox="1"/>
           <p:nvPr/>
         </p:nvSpPr>
@@ -7794,7 +7794,7 @@
       </p:sp>
       <p:sp>
         <p:nvSpPr>
-          <p:cNvPr id="36" name=""/>
+          <p:cNvPr id="36" name="Shape 36"/>
           <p:cNvSpPr/>
           <p:nvPr/>
         </p:nvSpPr>
@@ -7816,7 +7816,7 @@
       </p:sp>
       <p:sp>
         <p:nvSpPr>
-          <p:cNvPr id="37" name=""/>
+          <p:cNvPr id="37" name="Shape 37"/>
           <p:cNvSpPr txBox="1"/>
           <p:nvPr/>
         </p:nvSpPr>
@@ -7851,7 +7851,7 @@
       </p:sp>
       <p:sp>
         <p:nvSpPr>
-          <p:cNvPr id="38" name=""/>
+          <p:cNvPr id="38" name="Shape 38"/>
           <p:cNvSpPr txBox="1"/>
           <p:nvPr/>
         </p:nvSpPr>
@@ -7886,7 +7886,7 @@
       </p:sp>
       <p:sp>
         <p:nvSpPr>
-          <p:cNvPr id="39" name=""/>
+          <p:cNvPr id="39" name="Shape 39"/>
           <p:cNvSpPr/>
           <p:nvPr/>
         </p:nvSpPr>
@@ -7908,7 +7908,7 @@
       </p:sp>
       <p:sp>
         <p:nvSpPr>
-          <p:cNvPr id="40" name=""/>
+          <p:cNvPr id="40" name="Shape 40"/>
           <p:cNvSpPr txBox="1"/>
           <p:nvPr/>
         </p:nvSpPr>
@@ -7943,7 +7943,7 @@
       </p:sp>
       <p:sp>
         <p:nvSpPr>
-          <p:cNvPr id="41" name=""/>
+          <p:cNvPr id="41" name="Shape 41"/>
           <p:cNvSpPr txBox="1"/>
           <p:nvPr/>
         </p:nvSpPr>
@@ -7978,7 +7978,7 @@
       </p:sp>
       <p:sp>
         <p:nvSpPr>
-          <p:cNvPr id="42" name=""/>
+          <p:cNvPr id="42" name="Shape 42"/>
           <p:cNvSpPr/>
           <p:nvPr/>
         </p:nvSpPr>
@@ -8000,7 +8000,7 @@
       </p:sp>
       <p:sp>
         <p:nvSpPr>
-          <p:cNvPr id="43" name=""/>
+          <p:cNvPr id="43" name="Shape 43"/>
           <p:cNvSpPr txBox="1"/>
           <p:nvPr/>
         </p:nvSpPr>
@@ -8035,7 +8035,7 @@
       </p:sp>
       <p:sp>
         <p:nvSpPr>
-          <p:cNvPr id="44" name=""/>
+          <p:cNvPr id="44" name="Shape 44"/>
           <p:cNvSpPr txBox="1"/>
           <p:nvPr/>
         </p:nvSpPr>
@@ -8070,7 +8070,7 @@
       </p:sp>
       <p:sp>
         <p:nvSpPr>
-          <p:cNvPr id="45" name=""/>
+          <p:cNvPr id="45" name="Shape 45"/>
           <p:cNvSpPr/>
           <p:nvPr/>
         </p:nvSpPr>
@@ -8092,7 +8092,7 @@
       </p:sp>
       <p:sp>
         <p:nvSpPr>
-          <p:cNvPr id="46" name=""/>
+          <p:cNvPr id="46" name="Shape 46"/>
           <p:cNvSpPr txBox="1"/>
           <p:nvPr/>
         </p:nvSpPr>
@@ -8138,14 +8138,14 @@
   <p:cSld>
     <p:spTree>
       <p:nvGrpSpPr>
-        <p:cNvPr id="1" name=""/>
+        <p:cNvPr id="1" name="Shape 1"/>
         <p:cNvGrpSpPr/>
         <p:nvPr/>
       </p:nvGrpSpPr>
       <p:grpSpPr/>
       <p:sp>
         <p:nvSpPr>
-          <p:cNvPr id="2" name=""/>
+          <p:cNvPr id="2" name="Shape 2"/>
           <p:cNvSpPr/>
           <p:nvPr/>
         </p:nvSpPr>
@@ -8167,7 +8167,7 @@
       </p:sp>
       <p:sp>
         <p:nvSpPr>
-          <p:cNvPr id="3" name=""/>
+          <p:cNvPr id="3" name="Shape 3"/>
           <p:cNvSpPr/>
           <p:nvPr/>
         </p:nvSpPr>
@@ -8189,7 +8189,7 @@
       </p:sp>
       <p:sp>
         <p:nvSpPr>
-          <p:cNvPr id="4" name=""/>
+          <p:cNvPr id="4" name="Shape 4"/>
           <p:cNvSpPr txBox="1"/>
           <p:nvPr/>
         </p:nvSpPr>
@@ -8224,7 +8224,7 @@
       </p:sp>
       <p:sp>
         <p:nvSpPr>
-          <p:cNvPr id="5" name=""/>
+          <p:cNvPr id="5" name="Shape 5"/>
           <p:cNvSpPr txBox="1"/>
           <p:nvPr/>
         </p:nvSpPr>
@@ -8259,7 +8259,7 @@
       </p:sp>
       <p:pic>
         <p:nvPicPr>
-          <p:cNvPr id="6" name="" descr="logo_s.png"/>
+          <p:cNvPr id="6" name="Shape 6" descr="logo_s.png"/>
           <p:cNvPicPr>
             <a:picLocks noChangeAspect="1"/>
           </p:cNvPicPr>
@@ -8283,7 +8283,7 @@
       </p:pic>
       <p:sp>
         <p:nvSpPr>
-          <p:cNvPr id="7" name=""/>
+          <p:cNvPr id="7" name="Shape 7"/>
           <p:cNvSpPr/>
           <p:nvPr/>
         </p:nvSpPr>
@@ -8305,7 +8305,7 @@
       </p:sp>
       <p:sp>
         <p:nvSpPr>
-          <p:cNvPr id="8" name=""/>
+          <p:cNvPr id="8" name="Shape 8"/>
           <p:cNvSpPr txBox="1"/>
           <p:nvPr/>
         </p:nvSpPr>
@@ -8340,7 +8340,7 @@
       </p:sp>
       <p:sp>
         <p:nvSpPr>
-          <p:cNvPr id="9" name=""/>
+          <p:cNvPr id="9" name="Shape 9"/>
           <p:cNvSpPr txBox="1"/>
           <p:nvPr/>
         </p:nvSpPr>
@@ -8375,7 +8375,7 @@
       </p:sp>
       <p:sp>
         <p:nvSpPr>
-          <p:cNvPr id="10" name=""/>
+          <p:cNvPr id="10" name="Shape 10"/>
           <p:cNvSpPr/>
           <p:nvPr/>
         </p:nvSpPr>
@@ -8399,7 +8399,7 @@
       </p:sp>
       <p:sp>
         <p:nvSpPr>
-          <p:cNvPr id="11" name=""/>
+          <p:cNvPr id="11" name="Shape 11"/>
           <p:cNvSpPr txBox="1"/>
           <p:nvPr/>
         </p:nvSpPr>
@@ -8434,7 +8434,7 @@
       </p:sp>
       <p:sp>
         <p:nvSpPr>
-          <p:cNvPr id="12" name=""/>
+          <p:cNvPr id="12" name="Shape 12"/>
           <p:cNvSpPr txBox="1"/>
           <p:nvPr/>
         </p:nvSpPr>
@@ -8469,7 +8469,7 @@
       </p:sp>
       <p:sp>
         <p:nvSpPr>
-          <p:cNvPr id="13" name=""/>
+          <p:cNvPr id="13" name="Shape 13"/>
           <p:cNvSpPr txBox="1"/>
           <p:nvPr/>
         </p:nvSpPr>
@@ -8524,7 +8524,7 @@
       </p:sp>
       <p:sp>
         <p:nvSpPr>
-          <p:cNvPr id="14" name=""/>
+          <p:cNvPr id="14" name="Shape 14"/>
           <p:cNvSpPr/>
           <p:nvPr/>
         </p:nvSpPr>
@@ -8550,7 +8550,7 @@
       </p:sp>
       <p:sp>
         <p:nvSpPr>
-          <p:cNvPr id="15" name=""/>
+          <p:cNvPr id="15" name="Shape 15"/>
           <p:cNvSpPr txBox="1"/>
           <p:nvPr/>
         </p:nvSpPr>
@@ -8585,7 +8585,7 @@
       </p:sp>
       <p:sp>
         <p:nvSpPr>
-          <p:cNvPr id="16" name=""/>
+          <p:cNvPr id="16" name="Shape 16"/>
           <p:cNvSpPr txBox="1"/>
           <p:nvPr/>
         </p:nvSpPr>
@@ -8651,14 +8651,14 @@
   <p:cSld>
     <p:spTree>
       <p:nvGrpSpPr>
-        <p:cNvPr id="1" name=""/>
+        <p:cNvPr id="1" name="Shape 1"/>
         <p:cNvGrpSpPr/>
         <p:nvPr/>
       </p:nvGrpSpPr>
       <p:grpSpPr/>
       <p:sp>
         <p:nvSpPr>
-          <p:cNvPr id="2" name=""/>
+          <p:cNvPr id="2" name="Shape 2"/>
           <p:cNvSpPr/>
           <p:nvPr/>
         </p:nvSpPr>
@@ -8680,7 +8680,7 @@
       </p:sp>
       <p:sp>
         <p:nvSpPr>
-          <p:cNvPr id="3" name=""/>
+          <p:cNvPr id="3" name="Shape 3"/>
           <p:cNvSpPr/>
           <p:nvPr/>
         </p:nvSpPr>
@@ -8702,7 +8702,7 @@
       </p:sp>
       <p:sp>
         <p:nvSpPr>
-          <p:cNvPr id="4" name=""/>
+          <p:cNvPr id="4" name="Shape 4"/>
           <p:cNvSpPr txBox="1"/>
           <p:nvPr/>
         </p:nvSpPr>
@@ -8737,7 +8737,7 @@
       </p:sp>
       <p:sp>
         <p:nvSpPr>
-          <p:cNvPr id="5" name=""/>
+          <p:cNvPr id="5" name="Shape 5"/>
           <p:cNvSpPr txBox="1"/>
           <p:nvPr/>
         </p:nvSpPr>
@@ -8772,7 +8772,7 @@
       </p:sp>
       <p:pic>
         <p:nvPicPr>
-          <p:cNvPr id="6" name="" descr="logo_s.png"/>
+          <p:cNvPr id="6" name="Shape 6" descr="logo_s.png"/>
           <p:cNvPicPr>
             <a:picLocks noChangeAspect="1"/>
           </p:cNvPicPr>
@@ -8796,7 +8796,7 @@
       </p:pic>
       <p:sp>
         <p:nvSpPr>
-          <p:cNvPr id="7" name=""/>
+          <p:cNvPr id="7" name="Shape 7"/>
           <p:cNvSpPr/>
           <p:nvPr/>
         </p:nvSpPr>
@@ -8818,7 +8818,7 @@
       </p:sp>
       <p:sp>
         <p:nvSpPr>
-          <p:cNvPr id="8" name=""/>
+          <p:cNvPr id="8" name="Shape 8"/>
           <p:cNvSpPr txBox="1"/>
           <p:nvPr/>
         </p:nvSpPr>
@@ -8853,7 +8853,7 @@
       </p:sp>
       <p:sp>
         <p:nvSpPr>
-          <p:cNvPr id="9" name=""/>
+          <p:cNvPr id="9" name="Shape 9"/>
           <p:cNvSpPr txBox="1"/>
           <p:nvPr/>
         </p:nvSpPr>
@@ -8888,7 +8888,7 @@
       </p:sp>
       <p:sp>
         <p:nvSpPr>
-          <p:cNvPr id="10" name=""/>
+          <p:cNvPr id="10" name="Shape 10"/>
           <p:cNvSpPr/>
           <p:nvPr/>
         </p:nvSpPr>
@@ -8912,7 +8912,7 @@
       </p:sp>
       <p:sp>
         <p:nvSpPr>
-          <p:cNvPr id="11" name=""/>
+          <p:cNvPr id="11" name="Shape 11"/>
           <p:cNvSpPr txBox="1"/>
           <p:nvPr/>
         </p:nvSpPr>
@@ -8947,7 +8947,7 @@
       </p:sp>
       <p:sp>
         <p:nvSpPr>
-          <p:cNvPr id="12" name=""/>
+          <p:cNvPr id="12" name="Shape 12"/>
           <p:cNvSpPr txBox="1"/>
           <p:nvPr/>
         </p:nvSpPr>
@@ -8982,7 +8982,7 @@
       </p:sp>
       <p:sp>
         <p:nvSpPr>
-          <p:cNvPr id="13" name=""/>
+          <p:cNvPr id="13" name="Shape 13"/>
           <p:cNvSpPr txBox="1"/>
           <p:nvPr/>
         </p:nvSpPr>
@@ -9017,7 +9017,7 @@
       </p:sp>
       <p:sp>
         <p:nvSpPr>
-          <p:cNvPr id="14" name=""/>
+          <p:cNvPr id="14" name="Shape 14"/>
           <p:cNvSpPr/>
           <p:nvPr/>
         </p:nvSpPr>
@@ -9041,7 +9041,7 @@
       </p:sp>
       <p:sp>
         <p:nvSpPr>
-          <p:cNvPr id="15" name=""/>
+          <p:cNvPr id="15" name="Shape 15"/>
           <p:cNvSpPr txBox="1"/>
           <p:nvPr/>
         </p:nvSpPr>
@@ -9076,7 +9076,7 @@
       </p:sp>
       <p:sp>
         <p:nvSpPr>
-          <p:cNvPr id="16" name=""/>
+          <p:cNvPr id="16" name="Shape 16"/>
           <p:cNvSpPr txBox="1"/>
           <p:nvPr/>
         </p:nvSpPr>
@@ -9111,7 +9111,7 @@
       </p:sp>
       <p:sp>
         <p:nvSpPr>
-          <p:cNvPr id="17" name=""/>
+          <p:cNvPr id="17" name="Shape 17"/>
           <p:cNvSpPr txBox="1"/>
           <p:nvPr/>
         </p:nvSpPr>
@@ -9146,7 +9146,7 @@
       </p:sp>
       <p:sp>
         <p:nvSpPr>
-          <p:cNvPr id="18" name=""/>
+          <p:cNvPr id="18" name="Shape 18"/>
           <p:cNvSpPr/>
           <p:nvPr/>
         </p:nvSpPr>
@@ -9170,7 +9170,7 @@
       </p:sp>
       <p:sp>
         <p:nvSpPr>
-          <p:cNvPr id="19" name=""/>
+          <p:cNvPr id="19" name="Shape 19"/>
           <p:cNvSpPr txBox="1"/>
           <p:nvPr/>
         </p:nvSpPr>
@@ -9205,7 +9205,7 @@
       </p:sp>
       <p:sp>
         <p:nvSpPr>
-          <p:cNvPr id="20" name=""/>
+          <p:cNvPr id="20" name="Shape 20"/>
           <p:cNvSpPr txBox="1"/>
           <p:nvPr/>
         </p:nvSpPr>
@@ -9240,7 +9240,7 @@
       </p:sp>
       <p:sp>
         <p:nvSpPr>
-          <p:cNvPr id="21" name=""/>
+          <p:cNvPr id="21" name="Shape 21"/>
           <p:cNvSpPr txBox="1"/>
           <p:nvPr/>
         </p:nvSpPr>
@@ -9275,7 +9275,7 @@
       </p:sp>
       <p:sp>
         <p:nvSpPr>
-          <p:cNvPr id="22" name=""/>
+          <p:cNvPr id="22" name="Shape 22"/>
           <p:cNvSpPr txBox="1"/>
           <p:nvPr/>
         </p:nvSpPr>
@@ -9310,7 +9310,7 @@
       </p:sp>
       <p:sp>
         <p:nvSpPr>
-          <p:cNvPr id="23" name=""/>
+          <p:cNvPr id="23" name="Shape 23"/>
           <p:cNvSpPr txBox="1"/>
           <p:nvPr/>
         </p:nvSpPr>
@@ -9345,7 +9345,7 @@
       </p:sp>
       <p:sp>
         <p:nvSpPr>
-          <p:cNvPr id="24" name=""/>
+          <p:cNvPr id="24" name="Shape 24"/>
           <p:cNvSpPr/>
           <p:nvPr/>
         </p:nvSpPr>
@@ -9367,7 +9367,7 @@
       </p:sp>
       <p:sp>
         <p:nvSpPr>
-          <p:cNvPr id="25" name=""/>
+          <p:cNvPr id="25" name="Shape 25"/>
           <p:cNvSpPr txBox="1"/>
           <p:nvPr/>
         </p:nvSpPr>
@@ -9402,7 +9402,7 @@
       </p:sp>
       <p:sp>
         <p:nvSpPr>
-          <p:cNvPr id="26" name=""/>
+          <p:cNvPr id="26" name="Shape 26"/>
           <p:cNvSpPr txBox="1"/>
           <p:nvPr/>
         </p:nvSpPr>
@@ -9437,7 +9437,7 @@
       </p:sp>
       <p:sp>
         <p:nvSpPr>
-          <p:cNvPr id="27" name=""/>
+          <p:cNvPr id="27" name="Shape 27"/>
           <p:cNvSpPr/>
           <p:nvPr/>
         </p:nvSpPr>
@@ -9459,7 +9459,7 @@
       </p:sp>
       <p:sp>
         <p:nvSpPr>
-          <p:cNvPr id="28" name=""/>
+          <p:cNvPr id="28" name="Shape 28"/>
           <p:cNvSpPr txBox="1"/>
           <p:nvPr/>
         </p:nvSpPr>
@@ -9494,7 +9494,7 @@
       </p:sp>
       <p:sp>
         <p:nvSpPr>
-          <p:cNvPr id="29" name=""/>
+          <p:cNvPr id="29" name="Shape 29"/>
           <p:cNvSpPr txBox="1"/>
           <p:nvPr/>
         </p:nvSpPr>
@@ -9529,7 +9529,7 @@
       </p:sp>
       <p:sp>
         <p:nvSpPr>
-          <p:cNvPr id="30" name=""/>
+          <p:cNvPr id="30" name="Shape 30"/>
           <p:cNvSpPr/>
           <p:nvPr/>
         </p:nvSpPr>
@@ -9551,7 +9551,7 @@
       </p:sp>
       <p:sp>
         <p:nvSpPr>
-          <p:cNvPr id="31" name=""/>
+          <p:cNvPr id="31" name="Shape 31"/>
           <p:cNvSpPr txBox="1"/>
           <p:nvPr/>
         </p:nvSpPr>
@@ -9586,7 +9586,7 @@
       </p:sp>
       <p:sp>
         <p:nvSpPr>
-          <p:cNvPr id="32" name=""/>
+          <p:cNvPr id="32" name="Shape 32"/>
           <p:cNvSpPr txBox="1"/>
           <p:nvPr/>
         </p:nvSpPr>
@@ -9621,7 +9621,7 @@
       </p:sp>
       <p:sp>
         <p:nvSpPr>
-          <p:cNvPr id="33" name=""/>
+          <p:cNvPr id="33" name="Shape 33"/>
           <p:cNvSpPr/>
           <p:nvPr/>
         </p:nvSpPr>
@@ -9643,7 +9643,7 @@
       </p:sp>
       <p:sp>
         <p:nvSpPr>
-          <p:cNvPr id="34" name=""/>
+          <p:cNvPr id="34" name="Shape 34"/>
           <p:cNvSpPr txBox="1"/>
           <p:nvPr/>
         </p:nvSpPr>
@@ -9678,7 +9678,7 @@
       </p:sp>
       <p:sp>
         <p:nvSpPr>
-          <p:cNvPr id="35" name=""/>
+          <p:cNvPr id="35" name="Shape 35"/>
           <p:cNvSpPr txBox="1"/>
           <p:nvPr/>
         </p:nvSpPr>
@@ -9713,7 +9713,7 @@
       </p:sp>
       <p:sp>
         <p:nvSpPr>
-          <p:cNvPr id="36" name=""/>
+          <p:cNvPr id="36" name="Shape 36"/>
           <p:cNvSpPr/>
           <p:nvPr/>
         </p:nvSpPr>
@@ -9735,7 +9735,7 @@
       </p:sp>
       <p:sp>
         <p:nvSpPr>
-          <p:cNvPr id="37" name=""/>
+          <p:cNvPr id="37" name="Shape 37"/>
           <p:cNvSpPr txBox="1"/>
           <p:nvPr/>
         </p:nvSpPr>
@@ -9770,7 +9770,7 @@
       </p:sp>
       <p:sp>
         <p:nvSpPr>
-          <p:cNvPr id="38" name=""/>
+          <p:cNvPr id="38" name="Shape 38"/>
           <p:cNvSpPr txBox="1"/>
           <p:nvPr/>
         </p:nvSpPr>
@@ -9805,7 +9805,7 @@
       </p:sp>
       <p:sp>
         <p:nvSpPr>
-          <p:cNvPr id="39" name=""/>
+          <p:cNvPr id="39" name="Shape 39"/>
           <p:cNvSpPr/>
           <p:nvPr/>
         </p:nvSpPr>
@@ -9827,7 +9827,7 @@
       </p:sp>
       <p:sp>
         <p:nvSpPr>
-          <p:cNvPr id="40" name=""/>
+          <p:cNvPr id="40" name="Shape 40"/>
           <p:cNvSpPr txBox="1"/>
           <p:nvPr/>
         </p:nvSpPr>
@@ -9862,7 +9862,7 @@
       </p:sp>
       <p:sp>
         <p:nvSpPr>
-          <p:cNvPr id="41" name=""/>
+          <p:cNvPr id="41" name="Shape 41"/>
           <p:cNvSpPr txBox="1"/>
           <p:nvPr/>
         </p:nvSpPr>
@@ -9897,7 +9897,7 @@
       </p:sp>
       <p:sp>
         <p:nvSpPr>
-          <p:cNvPr id="42" name=""/>
+          <p:cNvPr id="42" name="Shape 42"/>
           <p:cNvSpPr/>
           <p:nvPr/>
         </p:nvSpPr>
@@ -9919,7 +9919,7 @@
       </p:sp>
       <p:sp>
         <p:nvSpPr>
-          <p:cNvPr id="43" name=""/>
+          <p:cNvPr id="43" name="Shape 43"/>
           <p:cNvSpPr txBox="1"/>
           <p:nvPr/>
         </p:nvSpPr>
@@ -9954,7 +9954,7 @@
       </p:sp>
       <p:sp>
         <p:nvSpPr>
-          <p:cNvPr id="44" name=""/>
+          <p:cNvPr id="44" name="Shape 44"/>
           <p:cNvSpPr txBox="1"/>
           <p:nvPr/>
         </p:nvSpPr>
@@ -9989,7 +9989,7 @@
       </p:sp>
       <p:sp>
         <p:nvSpPr>
-          <p:cNvPr id="45" name=""/>
+          <p:cNvPr id="45" name="Shape 45"/>
           <p:cNvSpPr/>
           <p:nvPr/>
         </p:nvSpPr>
@@ -10011,7 +10011,7 @@
       </p:sp>
       <p:sp>
         <p:nvSpPr>
-          <p:cNvPr id="46" name=""/>
+          <p:cNvPr id="46" name="Shape 46"/>
           <p:cNvSpPr txBox="1"/>
           <p:nvPr/>
         </p:nvSpPr>
@@ -10046,7 +10046,7 @@
       </p:sp>
       <p:sp>
         <p:nvSpPr>
-          <p:cNvPr id="47" name=""/>
+          <p:cNvPr id="47" name="Shape 47"/>
           <p:cNvSpPr txBox="1"/>
           <p:nvPr/>
         </p:nvSpPr>
@@ -10081,7 +10081,7 @@
       </p:sp>
       <p:sp>
         <p:nvSpPr>
-          <p:cNvPr id="48" name=""/>
+          <p:cNvPr id="48" name="Shape 48"/>
           <p:cNvSpPr/>
           <p:nvPr/>
         </p:nvSpPr>
@@ -10103,7 +10103,7 @@
       </p:sp>
       <p:sp>
         <p:nvSpPr>
-          <p:cNvPr id="49" name=""/>
+          <p:cNvPr id="49" name="Shape 49"/>
           <p:cNvSpPr txBox="1"/>
           <p:nvPr/>
         </p:nvSpPr>
@@ -10138,7 +10138,7 @@
       </p:sp>
       <p:sp>
         <p:nvSpPr>
-          <p:cNvPr id="50" name=""/>
+          <p:cNvPr id="50" name="Shape 50"/>
           <p:cNvSpPr txBox="1"/>
           <p:nvPr/>
         </p:nvSpPr>
@@ -10173,7 +10173,7 @@
       </p:sp>
       <p:sp>
         <p:nvSpPr>
-          <p:cNvPr id="51" name=""/>
+          <p:cNvPr id="51" name="Shape 51"/>
           <p:cNvSpPr/>
           <p:nvPr/>
         </p:nvSpPr>
@@ -10195,7 +10195,7 @@
       </p:sp>
       <p:sp>
         <p:nvSpPr>
-          <p:cNvPr id="52" name=""/>
+          <p:cNvPr id="52" name="Shape 52"/>
           <p:cNvSpPr txBox="1"/>
           <p:nvPr/>
         </p:nvSpPr>
@@ -10241,14 +10241,14 @@
   <p:cSld>
     <p:spTree>
       <p:nvGrpSpPr>
-        <p:cNvPr id="1" name=""/>
+        <p:cNvPr id="1" name="Shape 1"/>
         <p:cNvGrpSpPr/>
         <p:nvPr/>
       </p:nvGrpSpPr>
       <p:grpSpPr/>
       <p:sp>
         <p:nvSpPr>
-          <p:cNvPr id="2" name=""/>
+          <p:cNvPr id="2" name="Shape 2"/>
           <p:cNvSpPr/>
           <p:nvPr/>
         </p:nvSpPr>
@@ -10270,7 +10270,7 @@
       </p:sp>
       <p:sp>
         <p:nvSpPr>
-          <p:cNvPr id="3" name=""/>
+          <p:cNvPr id="3" name="Shape 3"/>
           <p:cNvSpPr/>
           <p:nvPr/>
         </p:nvSpPr>
@@ -10292,7 +10292,7 @@
       </p:sp>
       <p:sp>
         <p:nvSpPr>
-          <p:cNvPr id="4" name=""/>
+          <p:cNvPr id="4" name="Shape 4"/>
           <p:cNvSpPr txBox="1"/>
           <p:nvPr/>
         </p:nvSpPr>
@@ -10327,7 +10327,7 @@
       </p:sp>
       <p:sp>
         <p:nvSpPr>
-          <p:cNvPr id="5" name=""/>
+          <p:cNvPr id="5" name="Shape 5"/>
           <p:cNvSpPr txBox="1"/>
           <p:nvPr/>
         </p:nvSpPr>
@@ -10362,7 +10362,7 @@
       </p:sp>
       <p:pic>
         <p:nvPicPr>
-          <p:cNvPr id="6" name="" descr="logo_s.png"/>
+          <p:cNvPr id="6" name="Shape 6" descr="logo_s.png"/>
           <p:cNvPicPr>
             <a:picLocks noChangeAspect="1"/>
           </p:cNvPicPr>
@@ -10386,7 +10386,7 @@
       </p:pic>
       <p:sp>
         <p:nvSpPr>
-          <p:cNvPr id="7" name=""/>
+          <p:cNvPr id="7" name="Shape 7"/>
           <p:cNvSpPr/>
           <p:nvPr/>
         </p:nvSpPr>
@@ -10408,7 +10408,7 @@
       </p:sp>
       <p:sp>
         <p:nvSpPr>
-          <p:cNvPr id="8" name=""/>
+          <p:cNvPr id="8" name="Shape 8"/>
           <p:cNvSpPr txBox="1"/>
           <p:nvPr/>
         </p:nvSpPr>
@@ -10443,7 +10443,7 @@
       </p:sp>
       <p:sp>
         <p:nvSpPr>
-          <p:cNvPr id="9" name=""/>
+          <p:cNvPr id="9" name="Shape 9"/>
           <p:cNvSpPr txBox="1"/>
           <p:nvPr/>
         </p:nvSpPr>
@@ -10478,7 +10478,7 @@
       </p:sp>
       <p:graphicFrame>
         <p:nvGraphicFramePr>
-          <p:cNvPr id="10" name=""/>
+          <p:cNvPr id="10" name="Shape 10"/>
           <p:cNvGraphicFramePr>
             <a:graphicFrameLocks noGrp="1"/>
           </p:cNvGraphicFramePr>
@@ -11269,14 +11269,14 @@
   <p:cSld>
     <p:spTree>
       <p:nvGrpSpPr>
-        <p:cNvPr id="1" name=""/>
+        <p:cNvPr id="1" name="Shape 1"/>
         <p:cNvGrpSpPr/>
         <p:nvPr/>
       </p:nvGrpSpPr>
       <p:grpSpPr/>
       <p:sp>
         <p:nvSpPr>
-          <p:cNvPr id="2" name=""/>
+          <p:cNvPr id="2" name="Shape 2"/>
           <p:cNvSpPr/>
           <p:nvPr/>
         </p:nvSpPr>
@@ -11298,7 +11298,7 @@
       </p:sp>
       <p:sp>
         <p:nvSpPr>
-          <p:cNvPr id="3" name=""/>
+          <p:cNvPr id="3" name="Shape 3"/>
           <p:cNvSpPr/>
           <p:nvPr/>
         </p:nvSpPr>
@@ -11320,7 +11320,7 @@
       </p:sp>
       <p:sp>
         <p:nvSpPr>
-          <p:cNvPr id="4" name=""/>
+          <p:cNvPr id="4" name="Shape 4"/>
           <p:cNvSpPr txBox="1"/>
           <p:nvPr/>
         </p:nvSpPr>
@@ -11355,7 +11355,7 @@
       </p:sp>
       <p:sp>
         <p:nvSpPr>
-          <p:cNvPr id="5" name=""/>
+          <p:cNvPr id="5" name="Shape 5"/>
           <p:cNvSpPr txBox="1"/>
           <p:nvPr/>
         </p:nvSpPr>
@@ -11390,7 +11390,7 @@
       </p:sp>
       <p:pic>
         <p:nvPicPr>
-          <p:cNvPr id="6" name="" descr="logo_s.png"/>
+          <p:cNvPr id="6" name="Shape 6" descr="logo_s.png"/>
           <p:cNvPicPr>
             <a:picLocks noChangeAspect="1"/>
           </p:cNvPicPr>
@@ -11414,7 +11414,7 @@
       </p:pic>
       <p:sp>
         <p:nvSpPr>
-          <p:cNvPr id="7" name=""/>
+          <p:cNvPr id="7" name="Shape 7"/>
           <p:cNvSpPr/>
           <p:nvPr/>
         </p:nvSpPr>
@@ -11438,7 +11438,7 @@
       </p:sp>
       <p:sp>
         <p:nvSpPr>
-          <p:cNvPr id="8" name=""/>
+          <p:cNvPr id="8" name="Shape 8"/>
           <p:cNvSpPr txBox="1"/>
           <p:nvPr/>
         </p:nvSpPr>
@@ -11473,7 +11473,7 @@
       </p:sp>
       <p:sp>
         <p:nvSpPr>
-          <p:cNvPr id="9" name=""/>
+          <p:cNvPr id="9" name="Shape 9"/>
           <p:cNvSpPr txBox="1"/>
           <p:nvPr/>
         </p:nvSpPr>
@@ -11508,7 +11508,7 @@
       </p:sp>
       <p:sp>
         <p:nvSpPr>
-          <p:cNvPr id="10" name=""/>
+          <p:cNvPr id="10" name="Shape 10"/>
           <p:cNvSpPr txBox="1"/>
           <p:nvPr/>
         </p:nvSpPr>
@@ -11543,7 +11543,7 @@
       </p:sp>
       <p:sp>
         <p:nvSpPr>
-          <p:cNvPr id="11" name=""/>
+          <p:cNvPr id="11" name="Shape 11"/>
           <p:cNvSpPr/>
           <p:nvPr/>
         </p:nvSpPr>
@@ -11567,7 +11567,7 @@
       </p:sp>
       <p:sp>
         <p:nvSpPr>
-          <p:cNvPr id="12" name=""/>
+          <p:cNvPr id="12" name="Shape 12"/>
           <p:cNvSpPr txBox="1"/>
           <p:nvPr/>
         </p:nvSpPr>
@@ -11602,7 +11602,7 @@
       </p:sp>
       <p:sp>
         <p:nvSpPr>
-          <p:cNvPr id="13" name=""/>
+          <p:cNvPr id="13" name="Shape 13"/>
           <p:cNvSpPr txBox="1"/>
           <p:nvPr/>
         </p:nvSpPr>
@@ -11637,7 +11637,7 @@
       </p:sp>
       <p:sp>
         <p:nvSpPr>
-          <p:cNvPr id="14" name=""/>
+          <p:cNvPr id="14" name="Shape 14"/>
           <p:cNvSpPr txBox="1"/>
           <p:nvPr/>
         </p:nvSpPr>
@@ -11672,7 +11672,7 @@
       </p:sp>
       <p:sp>
         <p:nvSpPr>
-          <p:cNvPr id="15" name=""/>
+          <p:cNvPr id="15" name="Shape 15"/>
           <p:cNvSpPr/>
           <p:nvPr/>
         </p:nvSpPr>
@@ -11696,7 +11696,7 @@
       </p:sp>
       <p:sp>
         <p:nvSpPr>
-          <p:cNvPr id="16" name=""/>
+          <p:cNvPr id="16" name="Shape 16"/>
           <p:cNvSpPr txBox="1"/>
           <p:nvPr/>
         </p:nvSpPr>
@@ -11731,7 +11731,7 @@
       </p:sp>
       <p:sp>
         <p:nvSpPr>
-          <p:cNvPr id="17" name=""/>
+          <p:cNvPr id="17" name="Shape 17"/>
           <p:cNvSpPr txBox="1"/>
           <p:nvPr/>
         </p:nvSpPr>
@@ -11766,7 +11766,7 @@
       </p:sp>
       <p:sp>
         <p:nvSpPr>
-          <p:cNvPr id="18" name=""/>
+          <p:cNvPr id="18" name="Shape 18"/>
           <p:cNvSpPr txBox="1"/>
           <p:nvPr/>
         </p:nvSpPr>
@@ -11801,7 +11801,7 @@
       </p:sp>
       <p:sp>
         <p:nvSpPr>
-          <p:cNvPr id="19" name=""/>
+          <p:cNvPr id="19" name="Shape 19"/>
           <p:cNvSpPr/>
           <p:nvPr/>
         </p:nvSpPr>
@@ -11825,7 +11825,7 @@
       </p:sp>
       <p:sp>
         <p:nvSpPr>
-          <p:cNvPr id="20" name=""/>
+          <p:cNvPr id="20" name="Shape 20"/>
           <p:cNvSpPr txBox="1"/>
           <p:nvPr/>
         </p:nvSpPr>
@@ -11860,7 +11860,7 @@
       </p:sp>
       <p:sp>
         <p:nvSpPr>
-          <p:cNvPr id="21" name=""/>
+          <p:cNvPr id="21" name="Shape 21"/>
           <p:cNvSpPr txBox="1"/>
           <p:nvPr/>
         </p:nvSpPr>
@@ -11895,7 +11895,7 @@
       </p:sp>
       <p:sp>
         <p:nvSpPr>
-          <p:cNvPr id="22" name=""/>
+          <p:cNvPr id="22" name="Shape 22"/>
           <p:cNvSpPr txBox="1"/>
           <p:nvPr/>
         </p:nvSpPr>
@@ -11930,7 +11930,7 @@
       </p:sp>
       <p:sp>
         <p:nvSpPr>
-          <p:cNvPr id="23" name=""/>
+          <p:cNvPr id="23" name="Shape 23"/>
           <p:cNvSpPr txBox="1"/>
           <p:nvPr/>
         </p:nvSpPr>
@@ -11965,7 +11965,7 @@
       </p:sp>
       <p:sp>
         <p:nvSpPr>
-          <p:cNvPr id="24" name=""/>
+          <p:cNvPr id="24" name="Shape 24"/>
           <p:cNvSpPr/>
           <p:nvPr/>
         </p:nvSpPr>
@@ -11987,7 +11987,7 @@
       </p:sp>
       <p:sp>
         <p:nvSpPr>
-          <p:cNvPr id="25" name=""/>
+          <p:cNvPr id="25" name="Shape 25"/>
           <p:cNvSpPr txBox="1"/>
           <p:nvPr/>
         </p:nvSpPr>
@@ -12022,7 +12022,7 @@
       </p:sp>
       <p:sp>
         <p:nvSpPr>
-          <p:cNvPr id="26" name=""/>
+          <p:cNvPr id="26" name="Shape 26"/>
           <p:cNvSpPr txBox="1"/>
           <p:nvPr/>
         </p:nvSpPr>
@@ -12057,7 +12057,7 @@
       </p:sp>
       <p:sp>
         <p:nvSpPr>
-          <p:cNvPr id="27" name=""/>
+          <p:cNvPr id="27" name="Shape 27"/>
           <p:cNvSpPr/>
           <p:nvPr/>
         </p:nvSpPr>
@@ -12079,7 +12079,7 @@
       </p:sp>
       <p:sp>
         <p:nvSpPr>
-          <p:cNvPr id="28" name=""/>
+          <p:cNvPr id="28" name="Shape 28"/>
           <p:cNvSpPr txBox="1"/>
           <p:nvPr/>
         </p:nvSpPr>
@@ -12114,7 +12114,7 @@
       </p:sp>
       <p:sp>
         <p:nvSpPr>
-          <p:cNvPr id="29" name=""/>
+          <p:cNvPr id="29" name="Shape 29"/>
           <p:cNvSpPr txBox="1"/>
           <p:nvPr/>
         </p:nvSpPr>
@@ -12149,7 +12149,7 @@
       </p:sp>
       <p:sp>
         <p:nvSpPr>
-          <p:cNvPr id="30" name=""/>
+          <p:cNvPr id="30" name="Shape 30"/>
           <p:cNvSpPr txBox="1"/>
           <p:nvPr/>
         </p:nvSpPr>
@@ -12184,7 +12184,7 @@
       </p:sp>
       <p:sp>
         <p:nvSpPr>
-          <p:cNvPr id="31" name=""/>
+          <p:cNvPr id="31" name="Shape 31"/>
           <p:cNvSpPr/>
           <p:nvPr/>
         </p:nvSpPr>
@@ -12206,7 +12206,7 @@
       </p:sp>
       <p:sp>
         <p:nvSpPr>
-          <p:cNvPr id="32" name=""/>
+          <p:cNvPr id="32" name="Shape 32"/>
           <p:cNvSpPr txBox="1"/>
           <p:nvPr/>
         </p:nvSpPr>
@@ -12241,7 +12241,7 @@
       </p:sp>
       <p:sp>
         <p:nvSpPr>
-          <p:cNvPr id="33" name=""/>
+          <p:cNvPr id="33" name="Shape 33"/>
           <p:cNvSpPr txBox="1"/>
           <p:nvPr/>
         </p:nvSpPr>
@@ -12276,7 +12276,7 @@
       </p:sp>
       <p:sp>
         <p:nvSpPr>
-          <p:cNvPr id="34" name=""/>
+          <p:cNvPr id="34" name="Shape 34"/>
           <p:cNvSpPr/>
           <p:nvPr/>
         </p:nvSpPr>
@@ -12298,7 +12298,7 @@
       </p:sp>
       <p:sp>
         <p:nvSpPr>
-          <p:cNvPr id="35" name=""/>
+          <p:cNvPr id="35" name="Shape 35"/>
           <p:cNvSpPr txBox="1"/>
           <p:nvPr/>
         </p:nvSpPr>
@@ -12333,7 +12333,7 @@
       </p:sp>
       <p:sp>
         <p:nvSpPr>
-          <p:cNvPr id="36" name=""/>
+          <p:cNvPr id="36" name="Shape 36"/>
           <p:cNvSpPr txBox="1"/>
           <p:nvPr/>
         </p:nvSpPr>
@@ -12368,7 +12368,7 @@
       </p:sp>
       <p:sp>
         <p:nvSpPr>
-          <p:cNvPr id="37" name=""/>
+          <p:cNvPr id="37" name="Shape 37"/>
           <p:cNvSpPr txBox="1"/>
           <p:nvPr/>
         </p:nvSpPr>
@@ -12403,7 +12403,7 @@
       </p:sp>
       <p:sp>
         <p:nvSpPr>
-          <p:cNvPr id="38" name=""/>
+          <p:cNvPr id="38" name="Shape 38"/>
           <p:cNvSpPr/>
           <p:nvPr/>
         </p:nvSpPr>
@@ -12425,7 +12425,7 @@
       </p:sp>
       <p:sp>
         <p:nvSpPr>
-          <p:cNvPr id="39" name=""/>
+          <p:cNvPr id="39" name="Shape 39"/>
           <p:cNvSpPr txBox="1"/>
           <p:nvPr/>
         </p:nvSpPr>
@@ -12460,7 +12460,7 @@
       </p:sp>
       <p:sp>
         <p:nvSpPr>
-          <p:cNvPr id="40" name=""/>
+          <p:cNvPr id="40" name="Shape 40"/>
           <p:cNvSpPr txBox="1"/>
           <p:nvPr/>
         </p:nvSpPr>
@@ -12495,7 +12495,7 @@
       </p:sp>
       <p:sp>
         <p:nvSpPr>
-          <p:cNvPr id="41" name=""/>
+          <p:cNvPr id="41" name="Shape 41"/>
           <p:cNvSpPr/>
           <p:nvPr/>
         </p:nvSpPr>
@@ -12517,7 +12517,7 @@
       </p:sp>
       <p:sp>
         <p:nvSpPr>
-          <p:cNvPr id="42" name=""/>
+          <p:cNvPr id="42" name="Shape 42"/>
           <p:cNvSpPr txBox="1"/>
           <p:nvPr/>
         </p:nvSpPr>
@@ -12552,7 +12552,7 @@
       </p:sp>
       <p:sp>
         <p:nvSpPr>
-          <p:cNvPr id="43" name=""/>
+          <p:cNvPr id="43" name="Shape 43"/>
           <p:cNvSpPr txBox="1"/>
           <p:nvPr/>
         </p:nvSpPr>
@@ -12587,7 +12587,7 @@
       </p:sp>
       <p:sp>
         <p:nvSpPr>
-          <p:cNvPr id="44" name=""/>
+          <p:cNvPr id="44" name="Shape 44"/>
           <p:cNvSpPr txBox="1"/>
           <p:nvPr/>
         </p:nvSpPr>
@@ -12622,7 +12622,7 @@
       </p:sp>
       <p:sp>
         <p:nvSpPr>
-          <p:cNvPr id="45" name=""/>
+          <p:cNvPr id="45" name="Shape 45"/>
           <p:cNvSpPr txBox="1"/>
           <p:nvPr/>
         </p:nvSpPr>
@@ -12668,14 +12668,14 @@
   <p:cSld>
     <p:spTree>
       <p:nvGrpSpPr>
-        <p:cNvPr id="1" name=""/>
+        <p:cNvPr id="1" name="Shape 1"/>
         <p:cNvGrpSpPr/>
         <p:nvPr/>
       </p:nvGrpSpPr>
       <p:grpSpPr/>
       <p:sp>
         <p:nvSpPr>
-          <p:cNvPr id="2" name=""/>
+          <p:cNvPr id="2" name="Shape 2"/>
           <p:cNvSpPr/>
           <p:nvPr/>
         </p:nvSpPr>
@@ -12697,7 +12697,7 @@
       </p:sp>
       <p:sp>
         <p:nvSpPr>
-          <p:cNvPr id="3" name=""/>
+          <p:cNvPr id="3" name="Shape 3"/>
           <p:cNvSpPr/>
           <p:nvPr/>
         </p:nvSpPr>
@@ -12719,7 +12719,7 @@
       </p:sp>
       <p:sp>
         <p:nvSpPr>
-          <p:cNvPr id="4" name=""/>
+          <p:cNvPr id="4" name="Shape 4"/>
           <p:cNvSpPr txBox="1"/>
           <p:nvPr/>
         </p:nvSpPr>
@@ -12754,7 +12754,7 @@
       </p:sp>
       <p:sp>
         <p:nvSpPr>
-          <p:cNvPr id="5" name=""/>
+          <p:cNvPr id="5" name="Shape 5"/>
           <p:cNvSpPr txBox="1"/>
           <p:nvPr/>
         </p:nvSpPr>
@@ -12789,7 +12789,7 @@
       </p:sp>
       <p:pic>
         <p:nvPicPr>
-          <p:cNvPr id="6" name="" descr="logo_s.png"/>
+          <p:cNvPr id="6" name="Shape 6" descr="logo_s.png"/>
           <p:cNvPicPr>
             <a:picLocks noChangeAspect="1"/>
           </p:cNvPicPr>
@@ -12813,7 +12813,7 @@
       </p:pic>
       <p:sp>
         <p:nvSpPr>
-          <p:cNvPr id="7" name=""/>
+          <p:cNvPr id="7" name="Shape 7"/>
           <p:cNvSpPr/>
           <p:nvPr/>
         </p:nvSpPr>
@@ -12835,7 +12835,7 @@
       </p:sp>
       <p:sp>
         <p:nvSpPr>
-          <p:cNvPr id="8" name=""/>
+          <p:cNvPr id="8" name="Shape 8"/>
           <p:cNvSpPr txBox="1"/>
           <p:nvPr/>
         </p:nvSpPr>
@@ -12870,7 +12870,7 @@
       </p:sp>
       <p:sp>
         <p:nvSpPr>
-          <p:cNvPr id="9" name=""/>
+          <p:cNvPr id="9" name="Shape 9"/>
           <p:cNvSpPr txBox="1"/>
           <p:nvPr/>
         </p:nvSpPr>
@@ -12905,7 +12905,7 @@
       </p:sp>
       <p:sp>
         <p:nvSpPr>
-          <p:cNvPr id="10" name=""/>
+          <p:cNvPr id="10" name="Shape 10"/>
           <p:cNvSpPr/>
           <p:nvPr/>
         </p:nvSpPr>
@@ -12929,7 +12929,7 @@
       </p:sp>
       <p:sp>
         <p:nvSpPr>
-          <p:cNvPr id="11" name=""/>
+          <p:cNvPr id="11" name="Shape 11"/>
           <p:cNvSpPr txBox="1"/>
           <p:nvPr/>
         </p:nvSpPr>
@@ -12964,7 +12964,7 @@
       </p:sp>
       <p:sp>
         <p:nvSpPr>
-          <p:cNvPr id="12" name=""/>
+          <p:cNvPr id="12" name="Shape 12"/>
           <p:cNvSpPr txBox="1"/>
           <p:nvPr/>
         </p:nvSpPr>
@@ -12999,7 +12999,7 @@
       </p:sp>
       <p:sp>
         <p:nvSpPr>
-          <p:cNvPr id="13" name=""/>
+          <p:cNvPr id="13" name="Shape 13"/>
           <p:cNvSpPr/>
           <p:nvPr/>
         </p:nvSpPr>
@@ -13023,7 +13023,7 @@
       </p:sp>
       <p:sp>
         <p:nvSpPr>
-          <p:cNvPr id="14" name=""/>
+          <p:cNvPr id="14" name="Shape 14"/>
           <p:cNvSpPr txBox="1"/>
           <p:nvPr/>
         </p:nvSpPr>
@@ -13058,7 +13058,7 @@
       </p:sp>
       <p:sp>
         <p:nvSpPr>
-          <p:cNvPr id="15" name=""/>
+          <p:cNvPr id="15" name="Shape 15"/>
           <p:cNvSpPr txBox="1"/>
           <p:nvPr/>
         </p:nvSpPr>
@@ -13093,7 +13093,7 @@
       </p:sp>
       <p:sp>
         <p:nvSpPr>
-          <p:cNvPr id="16" name=""/>
+          <p:cNvPr id="16" name="Shape 16"/>
           <p:cNvSpPr/>
           <p:nvPr/>
         </p:nvSpPr>
@@ -13117,7 +13117,7 @@
       </p:sp>
       <p:sp>
         <p:nvSpPr>
-          <p:cNvPr id="17" name=""/>
+          <p:cNvPr id="17" name="Shape 17"/>
           <p:cNvSpPr txBox="1"/>
           <p:nvPr/>
         </p:nvSpPr>
@@ -13152,7 +13152,7 @@
       </p:sp>
       <p:sp>
         <p:nvSpPr>
-          <p:cNvPr id="18" name=""/>
+          <p:cNvPr id="18" name="Shape 18"/>
           <p:cNvSpPr txBox="1"/>
           <p:nvPr/>
         </p:nvSpPr>
@@ -13187,7 +13187,7 @@
       </p:sp>
       <p:sp>
         <p:nvSpPr>
-          <p:cNvPr id="19" name=""/>
+          <p:cNvPr id="19" name="Shape 19"/>
           <p:cNvSpPr/>
           <p:nvPr/>
         </p:nvSpPr>
@@ -13211,7 +13211,7 @@
       </p:sp>
       <p:sp>
         <p:nvSpPr>
-          <p:cNvPr id="20" name=""/>
+          <p:cNvPr id="20" name="Shape 20"/>
           <p:cNvSpPr txBox="1"/>
           <p:nvPr/>
         </p:nvSpPr>
@@ -13246,7 +13246,7 @@
       </p:sp>
       <p:sp>
         <p:nvSpPr>
-          <p:cNvPr id="21" name=""/>
+          <p:cNvPr id="21" name="Shape 21"/>
           <p:cNvSpPr txBox="1"/>
           <p:nvPr/>
         </p:nvSpPr>
@@ -13281,7 +13281,7 @@
       </p:sp>
       <p:sp>
         <p:nvSpPr>
-          <p:cNvPr id="22" name=""/>
+          <p:cNvPr id="22" name="Shape 22"/>
           <p:cNvSpPr/>
           <p:nvPr/>
         </p:nvSpPr>
@@ -13307,7 +13307,7 @@
       </p:sp>
       <p:sp>
         <p:nvSpPr>
-          <p:cNvPr id="23" name=""/>
+          <p:cNvPr id="23" name="Shape 23"/>
           <p:cNvSpPr txBox="1"/>
           <p:nvPr/>
         </p:nvSpPr>
@@ -13342,7 +13342,7 @@
       </p:sp>
       <p:sp>
         <p:nvSpPr>
-          <p:cNvPr id="24" name=""/>
+          <p:cNvPr id="24" name="Shape 24"/>
           <p:cNvSpPr txBox="1"/>
           <p:nvPr/>
         </p:nvSpPr>
@@ -13397,7 +13397,7 @@
       </p:sp>
       <p:sp>
         <p:nvSpPr>
-          <p:cNvPr id="25" name=""/>
+          <p:cNvPr id="25" name="Shape 25"/>
           <p:cNvSpPr/>
           <p:nvPr/>
         </p:nvSpPr>
@@ -13423,7 +13423,7 @@
       </p:sp>
       <p:sp>
         <p:nvSpPr>
-          <p:cNvPr id="26" name=""/>
+          <p:cNvPr id="26" name="Shape 26"/>
           <p:cNvSpPr txBox="1"/>
           <p:nvPr/>
         </p:nvSpPr>
@@ -13458,7 +13458,7 @@
       </p:sp>
       <p:sp>
         <p:nvSpPr>
-          <p:cNvPr id="27" name=""/>
+          <p:cNvPr id="27" name="Shape 27"/>
           <p:cNvSpPr txBox="1"/>
           <p:nvPr/>
         </p:nvSpPr>
@@ -13545,7 +13545,7 @@
       </p:sp>
       <p:sp>
         <p:nvSpPr>
-          <p:cNvPr id="28" name=""/>
+          <p:cNvPr id="28" name="Shape 28"/>
           <p:cNvSpPr/>
           <p:nvPr/>
         </p:nvSpPr>
@@ -13571,7 +13571,7 @@
       </p:sp>
       <p:sp>
         <p:nvSpPr>
-          <p:cNvPr id="29" name=""/>
+          <p:cNvPr id="29" name="Shape 29"/>
           <p:cNvSpPr txBox="1"/>
           <p:nvPr/>
         </p:nvSpPr>
@@ -13606,7 +13606,7 @@
       </p:sp>
       <p:sp>
         <p:nvSpPr>
-          <p:cNvPr id="30" name=""/>
+          <p:cNvPr id="30" name="Shape 30"/>
           <p:cNvSpPr txBox="1"/>
           <p:nvPr/>
         </p:nvSpPr>
@@ -13704,14 +13704,14 @@
   <p:cSld>
     <p:spTree>
       <p:nvGrpSpPr>
-        <p:cNvPr id="1" name=""/>
+        <p:cNvPr id="1" name="Shape 1"/>
         <p:cNvGrpSpPr/>
         <p:nvPr/>
       </p:nvGrpSpPr>
       <p:grpSpPr/>
       <p:sp>
         <p:nvSpPr>
-          <p:cNvPr id="2" name=""/>
+          <p:cNvPr id="2" name="Shape 2"/>
           <p:cNvSpPr/>
           <p:nvPr/>
         </p:nvSpPr>
@@ -13733,7 +13733,7 @@
       </p:sp>
       <p:sp>
         <p:nvSpPr>
-          <p:cNvPr id="3" name=""/>
+          <p:cNvPr id="3" name="Shape 3"/>
           <p:cNvSpPr/>
           <p:nvPr/>
         </p:nvSpPr>
@@ -13755,7 +13755,7 @@
       </p:sp>
       <p:sp>
         <p:nvSpPr>
-          <p:cNvPr id="4" name=""/>
+          <p:cNvPr id="4" name="Shape 4"/>
           <p:cNvSpPr txBox="1"/>
           <p:nvPr/>
         </p:nvSpPr>
@@ -13790,7 +13790,7 @@
       </p:sp>
       <p:sp>
         <p:nvSpPr>
-          <p:cNvPr id="5" name=""/>
+          <p:cNvPr id="5" name="Shape 5"/>
           <p:cNvSpPr txBox="1"/>
           <p:nvPr/>
         </p:nvSpPr>
@@ -13825,7 +13825,7 @@
       </p:sp>
       <p:pic>
         <p:nvPicPr>
-          <p:cNvPr id="6" name="" descr="logo_s.png"/>
+          <p:cNvPr id="6" name="Shape 6" descr="logo_s.png"/>
           <p:cNvPicPr>
             <a:picLocks noChangeAspect="1"/>
           </p:cNvPicPr>
@@ -13849,7 +13849,7 @@
       </p:pic>
       <p:sp>
         <p:nvSpPr>
-          <p:cNvPr id="7" name=""/>
+          <p:cNvPr id="7" name="Shape 7"/>
           <p:cNvSpPr/>
           <p:nvPr/>
         </p:nvSpPr>
@@ -13871,7 +13871,7 @@
       </p:sp>
       <p:sp>
         <p:nvSpPr>
-          <p:cNvPr id="8" name=""/>
+          <p:cNvPr id="8" name="Shape 8"/>
           <p:cNvSpPr txBox="1"/>
           <p:nvPr/>
         </p:nvSpPr>
@@ -13906,7 +13906,7 @@
       </p:sp>
       <p:sp>
         <p:nvSpPr>
-          <p:cNvPr id="9" name=""/>
+          <p:cNvPr id="9" name="Shape 9"/>
           <p:cNvSpPr txBox="1"/>
           <p:nvPr/>
         </p:nvSpPr>
@@ -13941,7 +13941,7 @@
       </p:sp>
       <p:sp>
         <p:nvSpPr>
-          <p:cNvPr id="10" name=""/>
+          <p:cNvPr id="10" name="Shape 10"/>
           <p:cNvSpPr/>
           <p:nvPr/>
         </p:nvSpPr>
@@ -13965,7 +13965,7 @@
       </p:sp>
       <p:sp>
         <p:nvSpPr>
-          <p:cNvPr id="11" name=""/>
+          <p:cNvPr id="11" name="Shape 11"/>
           <p:cNvSpPr txBox="1"/>
           <p:nvPr/>
         </p:nvSpPr>
@@ -14000,7 +14000,7 @@
       </p:sp>
       <p:sp>
         <p:nvSpPr>
-          <p:cNvPr id="12" name=""/>
+          <p:cNvPr id="12" name="Shape 12"/>
           <p:cNvSpPr txBox="1"/>
           <p:nvPr/>
         </p:nvSpPr>
@@ -14035,7 +14035,7 @@
       </p:sp>
       <p:sp>
         <p:nvSpPr>
-          <p:cNvPr id="13" name=""/>
+          <p:cNvPr id="13" name="Shape 13"/>
           <p:cNvSpPr txBox="1"/>
           <p:nvPr/>
         </p:nvSpPr>
@@ -14070,7 +14070,7 @@
       </p:sp>
       <p:sp>
         <p:nvSpPr>
-          <p:cNvPr id="14" name=""/>
+          <p:cNvPr id="14" name="Shape 14"/>
           <p:cNvSpPr/>
           <p:nvPr/>
         </p:nvSpPr>
@@ -14094,7 +14094,7 @@
       </p:sp>
       <p:sp>
         <p:nvSpPr>
-          <p:cNvPr id="15" name=""/>
+          <p:cNvPr id="15" name="Shape 15"/>
           <p:cNvSpPr txBox="1"/>
           <p:nvPr/>
         </p:nvSpPr>
@@ -14129,7 +14129,7 @@
       </p:sp>
       <p:sp>
         <p:nvSpPr>
-          <p:cNvPr id="16" name=""/>
+          <p:cNvPr id="16" name="Shape 16"/>
           <p:cNvSpPr txBox="1"/>
           <p:nvPr/>
         </p:nvSpPr>
@@ -14164,7 +14164,7 @@
       </p:sp>
       <p:sp>
         <p:nvSpPr>
-          <p:cNvPr id="17" name=""/>
+          <p:cNvPr id="17" name="Shape 17"/>
           <p:cNvSpPr txBox="1"/>
           <p:nvPr/>
         </p:nvSpPr>
@@ -14199,7 +14199,7 @@
       </p:sp>
       <p:sp>
         <p:nvSpPr>
-          <p:cNvPr id="18" name=""/>
+          <p:cNvPr id="18" name="Shape 18"/>
           <p:cNvSpPr/>
           <p:nvPr/>
         </p:nvSpPr>
@@ -14223,7 +14223,7 @@
       </p:sp>
       <p:sp>
         <p:nvSpPr>
-          <p:cNvPr id="19" name=""/>
+          <p:cNvPr id="19" name="Shape 19"/>
           <p:cNvSpPr txBox="1"/>
           <p:nvPr/>
         </p:nvSpPr>
@@ -14258,7 +14258,7 @@
       </p:sp>
       <p:sp>
         <p:nvSpPr>
-          <p:cNvPr id="20" name=""/>
+          <p:cNvPr id="20" name="Shape 20"/>
           <p:cNvSpPr txBox="1"/>
           <p:nvPr/>
         </p:nvSpPr>
@@ -14293,7 +14293,7 @@
       </p:sp>
       <p:sp>
         <p:nvSpPr>
-          <p:cNvPr id="21" name=""/>
+          <p:cNvPr id="21" name="Shape 21"/>
           <p:cNvSpPr txBox="1"/>
           <p:nvPr/>
         </p:nvSpPr>
@@ -14328,7 +14328,7 @@
       </p:sp>
       <p:sp>
         <p:nvSpPr>
-          <p:cNvPr id="22" name=""/>
+          <p:cNvPr id="22" name="Shape 22"/>
           <p:cNvSpPr/>
           <p:nvPr/>
         </p:nvSpPr>
@@ -14352,7 +14352,7 @@
       </p:sp>
       <p:sp>
         <p:nvSpPr>
-          <p:cNvPr id="23" name=""/>
+          <p:cNvPr id="23" name="Shape 23"/>
           <p:cNvSpPr txBox="1"/>
           <p:nvPr/>
         </p:nvSpPr>
@@ -14387,7 +14387,7 @@
       </p:sp>
       <p:sp>
         <p:nvSpPr>
-          <p:cNvPr id="24" name=""/>
+          <p:cNvPr id="24" name="Shape 24"/>
           <p:cNvSpPr txBox="1"/>
           <p:nvPr/>
         </p:nvSpPr>
@@ -14422,7 +14422,7 @@
       </p:sp>
       <p:sp>
         <p:nvSpPr>
-          <p:cNvPr id="25" name=""/>
+          <p:cNvPr id="25" name="Shape 25"/>
           <p:cNvSpPr txBox="1"/>
           <p:nvPr/>
         </p:nvSpPr>
@@ -14457,7 +14457,7 @@
       </p:sp>
       <p:sp>
         <p:nvSpPr>
-          <p:cNvPr id="26" name=""/>
+          <p:cNvPr id="26" name="Shape 26"/>
           <p:cNvSpPr/>
           <p:nvPr/>
         </p:nvSpPr>
@@ -14481,7 +14481,7 @@
       </p:sp>
       <p:sp>
         <p:nvSpPr>
-          <p:cNvPr id="27" name=""/>
+          <p:cNvPr id="27" name="Shape 27"/>
           <p:cNvSpPr txBox="1"/>
           <p:nvPr/>
         </p:nvSpPr>
@@ -14516,7 +14516,7 @@
       </p:sp>
       <p:sp>
         <p:nvSpPr>
-          <p:cNvPr id="28" name=""/>
+          <p:cNvPr id="28" name="Shape 28"/>
           <p:cNvSpPr txBox="1"/>
           <p:nvPr/>
         </p:nvSpPr>
@@ -14551,7 +14551,7 @@
       </p:sp>
       <p:sp>
         <p:nvSpPr>
-          <p:cNvPr id="29" name=""/>
+          <p:cNvPr id="29" name="Shape 29"/>
           <p:cNvSpPr txBox="1"/>
           <p:nvPr/>
         </p:nvSpPr>
@@ -14586,7 +14586,7 @@
       </p:sp>
       <p:sp>
         <p:nvSpPr>
-          <p:cNvPr id="30" name=""/>
+          <p:cNvPr id="30" name="Shape 30"/>
           <p:cNvSpPr/>
           <p:nvPr/>
         </p:nvSpPr>
@@ -14610,7 +14610,7 @@
       </p:sp>
       <p:sp>
         <p:nvSpPr>
-          <p:cNvPr id="31" name=""/>
+          <p:cNvPr id="31" name="Shape 31"/>
           <p:cNvSpPr txBox="1"/>
           <p:nvPr/>
         </p:nvSpPr>
@@ -14645,7 +14645,7 @@
       </p:sp>
       <p:sp>
         <p:nvSpPr>
-          <p:cNvPr id="32" name=""/>
+          <p:cNvPr id="32" name="Shape 32"/>
           <p:cNvSpPr txBox="1"/>
           <p:nvPr/>
         </p:nvSpPr>
@@ -14680,7 +14680,7 @@
       </p:sp>
       <p:sp>
         <p:nvSpPr>
-          <p:cNvPr id="33" name=""/>
+          <p:cNvPr id="33" name="Shape 33"/>
           <p:cNvSpPr txBox="1"/>
           <p:nvPr/>
         </p:nvSpPr>
@@ -14726,14 +14726,14 @@
   <p:cSld>
     <p:spTree>
       <p:nvGrpSpPr>
-        <p:cNvPr id="1" name=""/>
+        <p:cNvPr id="1" name="Shape 1"/>
         <p:cNvGrpSpPr/>
         <p:nvPr/>
       </p:nvGrpSpPr>
       <p:grpSpPr/>
       <p:sp>
         <p:nvSpPr>
-          <p:cNvPr id="2" name=""/>
+          <p:cNvPr id="2" name="Shape 2"/>
           <p:cNvSpPr/>
           <p:nvPr/>
         </p:nvSpPr>
@@ -14755,7 +14755,7 @@
       </p:sp>
       <p:sp>
         <p:nvSpPr>
-          <p:cNvPr id="3" name=""/>
+          <p:cNvPr id="3" name="Shape 3"/>
           <p:cNvSpPr/>
           <p:nvPr/>
         </p:nvSpPr>
@@ -14777,7 +14777,7 @@
       </p:sp>
       <p:sp>
         <p:nvSpPr>
-          <p:cNvPr id="4" name=""/>
+          <p:cNvPr id="4" name="Shape 4"/>
           <p:cNvSpPr txBox="1"/>
           <p:nvPr/>
         </p:nvSpPr>
@@ -14812,7 +14812,7 @@
       </p:sp>
       <p:sp>
         <p:nvSpPr>
-          <p:cNvPr id="5" name=""/>
+          <p:cNvPr id="5" name="Shape 5"/>
           <p:cNvSpPr txBox="1"/>
           <p:nvPr/>
         </p:nvSpPr>
@@ -14847,7 +14847,7 @@
       </p:sp>
       <p:pic>
         <p:nvPicPr>
-          <p:cNvPr id="6" name="" descr="logo_s.png"/>
+          <p:cNvPr id="6" name="Shape 6" descr="logo_s.png"/>
           <p:cNvPicPr>
             <a:picLocks noChangeAspect="1"/>
           </p:cNvPicPr>
@@ -14871,7 +14871,7 @@
       </p:pic>
       <p:sp>
         <p:nvSpPr>
-          <p:cNvPr id="7" name=""/>
+          <p:cNvPr id="7" name="Shape 7"/>
           <p:cNvSpPr/>
           <p:nvPr/>
         </p:nvSpPr>
@@ -14893,7 +14893,7 @@
       </p:sp>
       <p:sp>
         <p:nvSpPr>
-          <p:cNvPr id="8" name=""/>
+          <p:cNvPr id="8" name="Shape 8"/>
           <p:cNvSpPr txBox="1"/>
           <p:nvPr/>
         </p:nvSpPr>
@@ -14928,7 +14928,7 @@
       </p:sp>
       <p:sp>
         <p:nvSpPr>
-          <p:cNvPr id="9" name=""/>
+          <p:cNvPr id="9" name="Shape 9"/>
           <p:cNvSpPr txBox="1"/>
           <p:nvPr/>
         </p:nvSpPr>
@@ -14963,7 +14963,7 @@
       </p:sp>
       <p:graphicFrame>
         <p:nvGraphicFramePr>
-          <p:cNvPr id="10" name=""/>
+          <p:cNvPr id="10" name="Shape 10"/>
           <p:cNvGraphicFramePr>
             <a:graphicFrameLocks noGrp="1"/>
           </p:cNvGraphicFramePr>
@@ -15972,7 +15972,7 @@
       </p:graphicFrame>
       <p:sp>
         <p:nvSpPr>
-          <p:cNvPr id="11" name=""/>
+          <p:cNvPr id="11" name="Shape 11"/>
           <p:cNvSpPr/>
           <p:nvPr/>
         </p:nvSpPr>
@@ -15998,7 +15998,7 @@
       </p:sp>
       <p:sp>
         <p:nvSpPr>
-          <p:cNvPr id="12" name=""/>
+          <p:cNvPr id="12" name="Shape 12"/>
           <p:cNvSpPr txBox="1"/>
           <p:nvPr/>
         </p:nvSpPr>
@@ -16033,7 +16033,7 @@
       </p:sp>
       <p:sp>
         <p:nvSpPr>
-          <p:cNvPr id="13" name=""/>
+          <p:cNvPr id="13" name="Shape 13"/>
           <p:cNvSpPr txBox="1"/>
           <p:nvPr/>
         </p:nvSpPr>
@@ -16088,7 +16088,7 @@
       </p:sp>
       <p:sp>
         <p:nvSpPr>
-          <p:cNvPr id="14" name=""/>
+          <p:cNvPr id="14" name="Shape 14"/>
           <p:cNvSpPr/>
           <p:nvPr/>
         </p:nvSpPr>
@@ -16114,7 +16114,7 @@
       </p:sp>
       <p:sp>
         <p:nvSpPr>
-          <p:cNvPr id="15" name=""/>
+          <p:cNvPr id="15" name="Shape 15"/>
           <p:cNvSpPr txBox="1"/>
           <p:nvPr/>
         </p:nvSpPr>
@@ -16149,7 +16149,7 @@
       </p:sp>
       <p:sp>
         <p:nvSpPr>
-          <p:cNvPr id="16" name=""/>
+          <p:cNvPr id="16" name="Shape 16"/>
           <p:cNvSpPr txBox="1"/>
           <p:nvPr/>
         </p:nvSpPr>
@@ -16215,14 +16215,14 @@
   <p:cSld>
     <p:spTree>
       <p:nvGrpSpPr>
-        <p:cNvPr id="1" name=""/>
+        <p:cNvPr id="1" name="Shape 1"/>
         <p:cNvGrpSpPr/>
         <p:nvPr/>
       </p:nvGrpSpPr>
       <p:grpSpPr/>
       <p:sp>
         <p:nvSpPr>
-          <p:cNvPr id="2" name=""/>
+          <p:cNvPr id="2" name="Shape 2"/>
           <p:cNvSpPr/>
           <p:nvPr/>
         </p:nvSpPr>
@@ -16244,7 +16244,7 @@
       </p:sp>
       <p:sp>
         <p:nvSpPr>
-          <p:cNvPr id="3" name=""/>
+          <p:cNvPr id="3" name="Shape 3"/>
           <p:cNvSpPr/>
           <p:nvPr/>
         </p:nvSpPr>
@@ -16266,7 +16266,7 @@
       </p:sp>
       <p:sp>
         <p:nvSpPr>
-          <p:cNvPr id="4" name=""/>
+          <p:cNvPr id="4" name="Shape 4"/>
           <p:cNvSpPr txBox="1"/>
           <p:nvPr/>
         </p:nvSpPr>
@@ -16301,7 +16301,7 @@
       </p:sp>
       <p:sp>
         <p:nvSpPr>
-          <p:cNvPr id="5" name=""/>
+          <p:cNvPr id="5" name="Shape 5"/>
           <p:cNvSpPr txBox="1"/>
           <p:nvPr/>
         </p:nvSpPr>
@@ -16336,7 +16336,7 @@
       </p:sp>
       <p:pic>
         <p:nvPicPr>
-          <p:cNvPr id="6" name="" descr="logo_s.png"/>
+          <p:cNvPr id="6" name="Shape 6" descr="logo_s.png"/>
           <p:cNvPicPr>
             <a:picLocks noChangeAspect="1"/>
           </p:cNvPicPr>
@@ -16360,7 +16360,7 @@
       </p:pic>
       <p:sp>
         <p:nvSpPr>
-          <p:cNvPr id="7" name=""/>
+          <p:cNvPr id="7" name="Shape 7"/>
           <p:cNvSpPr/>
           <p:nvPr/>
         </p:nvSpPr>
@@ -16382,7 +16382,7 @@
       </p:sp>
       <p:sp>
         <p:nvSpPr>
-          <p:cNvPr id="8" name=""/>
+          <p:cNvPr id="8" name="Shape 8"/>
           <p:cNvSpPr txBox="1"/>
           <p:nvPr/>
         </p:nvSpPr>
@@ -16417,7 +16417,7 @@
       </p:sp>
       <p:sp>
         <p:nvSpPr>
-          <p:cNvPr id="9" name=""/>
+          <p:cNvPr id="9" name="Shape 9"/>
           <p:cNvSpPr txBox="1"/>
           <p:nvPr/>
         </p:nvSpPr>
@@ -16452,7 +16452,7 @@
       </p:sp>
       <p:sp>
         <p:nvSpPr>
-          <p:cNvPr id="10" name=""/>
+          <p:cNvPr id="10" name="Shape 10"/>
           <p:cNvSpPr/>
           <p:nvPr/>
         </p:nvSpPr>
@@ -16476,7 +16476,7 @@
       </p:sp>
       <p:sp>
         <p:nvSpPr>
-          <p:cNvPr id="11" name=""/>
+          <p:cNvPr id="11" name="Shape 11"/>
           <p:cNvSpPr txBox="1"/>
           <p:nvPr/>
         </p:nvSpPr>
@@ -16511,7 +16511,7 @@
       </p:sp>
       <p:sp>
         <p:nvSpPr>
-          <p:cNvPr id="12" name=""/>
+          <p:cNvPr id="12" name="Shape 12"/>
           <p:cNvSpPr txBox="1"/>
           <p:nvPr/>
         </p:nvSpPr>
@@ -16546,7 +16546,7 @@
       </p:sp>
       <p:sp>
         <p:nvSpPr>
-          <p:cNvPr id="13" name=""/>
+          <p:cNvPr id="13" name="Shape 13"/>
           <p:cNvSpPr txBox="1"/>
           <p:nvPr/>
         </p:nvSpPr>
@@ -16581,7 +16581,7 @@
       </p:sp>
       <p:sp>
         <p:nvSpPr>
-          <p:cNvPr id="14" name=""/>
+          <p:cNvPr id="14" name="Shape 14"/>
           <p:cNvSpPr/>
           <p:nvPr/>
         </p:nvSpPr>
@@ -16605,7 +16605,7 @@
       </p:sp>
       <p:sp>
         <p:nvSpPr>
-          <p:cNvPr id="15" name=""/>
+          <p:cNvPr id="15" name="Shape 15"/>
           <p:cNvSpPr txBox="1"/>
           <p:nvPr/>
         </p:nvSpPr>
@@ -16640,7 +16640,7 @@
       </p:sp>
       <p:sp>
         <p:nvSpPr>
-          <p:cNvPr id="16" name=""/>
+          <p:cNvPr id="16" name="Shape 16"/>
           <p:cNvSpPr txBox="1"/>
           <p:nvPr/>
         </p:nvSpPr>
@@ -16675,7 +16675,7 @@
       </p:sp>
       <p:sp>
         <p:nvSpPr>
-          <p:cNvPr id="17" name=""/>
+          <p:cNvPr id="17" name="Shape 17"/>
           <p:cNvSpPr txBox="1"/>
           <p:nvPr/>
         </p:nvSpPr>
@@ -16710,7 +16710,7 @@
       </p:sp>
       <p:sp>
         <p:nvSpPr>
-          <p:cNvPr id="18" name=""/>
+          <p:cNvPr id="18" name="Shape 18"/>
           <p:cNvSpPr/>
           <p:nvPr/>
         </p:nvSpPr>
@@ -16734,7 +16734,7 @@
       </p:sp>
       <p:sp>
         <p:nvSpPr>
-          <p:cNvPr id="19" name=""/>
+          <p:cNvPr id="19" name="Shape 19"/>
           <p:cNvSpPr txBox="1"/>
           <p:nvPr/>
         </p:nvSpPr>
@@ -16769,7 +16769,7 @@
       </p:sp>
       <p:sp>
         <p:nvSpPr>
-          <p:cNvPr id="20" name=""/>
+          <p:cNvPr id="20" name="Shape 20"/>
           <p:cNvSpPr txBox="1"/>
           <p:nvPr/>
         </p:nvSpPr>
@@ -16804,7 +16804,7 @@
       </p:sp>
       <p:sp>
         <p:nvSpPr>
-          <p:cNvPr id="21" name=""/>
+          <p:cNvPr id="21" name="Shape 21"/>
           <p:cNvSpPr txBox="1"/>
           <p:nvPr/>
         </p:nvSpPr>
@@ -16839,7 +16839,7 @@
       </p:sp>
       <p:sp>
         <p:nvSpPr>
-          <p:cNvPr id="22" name=""/>
+          <p:cNvPr id="22" name="Shape 22"/>
           <p:cNvSpPr/>
           <p:nvPr/>
         </p:nvSpPr>
@@ -16863,7 +16863,7 @@
       </p:sp>
       <p:sp>
         <p:nvSpPr>
-          <p:cNvPr id="23" name=""/>
+          <p:cNvPr id="23" name="Shape 23"/>
           <p:cNvSpPr txBox="1"/>
           <p:nvPr/>
         </p:nvSpPr>
@@ -16898,7 +16898,7 @@
       </p:sp>
       <p:sp>
         <p:nvSpPr>
-          <p:cNvPr id="24" name=""/>
+          <p:cNvPr id="24" name="Shape 24"/>
           <p:cNvSpPr txBox="1"/>
           <p:nvPr/>
         </p:nvSpPr>
@@ -16933,7 +16933,7 @@
       </p:sp>
       <p:sp>
         <p:nvSpPr>
-          <p:cNvPr id="25" name=""/>
+          <p:cNvPr id="25" name="Shape 25"/>
           <p:cNvSpPr txBox="1"/>
           <p:nvPr/>
         </p:nvSpPr>
@@ -16968,7 +16968,7 @@
       </p:sp>
       <p:sp>
         <p:nvSpPr>
-          <p:cNvPr id="26" name=""/>
+          <p:cNvPr id="26" name="Shape 26"/>
           <p:cNvSpPr/>
           <p:nvPr/>
         </p:nvSpPr>
@@ -16990,7 +16990,7 @@
       </p:sp>
       <p:sp>
         <p:nvSpPr>
-          <p:cNvPr id="27" name=""/>
+          <p:cNvPr id="27" name="Shape 27"/>
           <p:cNvSpPr txBox="1"/>
           <p:nvPr/>
         </p:nvSpPr>
@@ -17025,7 +17025,7 @@
       </p:sp>
       <p:sp>
         <p:nvSpPr>
-          <p:cNvPr id="28" name=""/>
+          <p:cNvPr id="28" name="Shape 28"/>
           <p:cNvSpPr txBox="1"/>
           <p:nvPr/>
         </p:nvSpPr>
@@ -17060,7 +17060,7 @@
       </p:sp>
       <p:sp>
         <p:nvSpPr>
-          <p:cNvPr id="29" name=""/>
+          <p:cNvPr id="29" name="Shape 29"/>
           <p:cNvSpPr/>
           <p:nvPr/>
         </p:nvSpPr>
@@ -17082,7 +17082,7 @@
       </p:sp>
       <p:sp>
         <p:nvSpPr>
-          <p:cNvPr id="30" name=""/>
+          <p:cNvPr id="30" name="Shape 30"/>
           <p:cNvSpPr txBox="1"/>
           <p:nvPr/>
         </p:nvSpPr>
@@ -17117,7 +17117,7 @@
       </p:sp>
       <p:sp>
         <p:nvSpPr>
-          <p:cNvPr id="31" name=""/>
+          <p:cNvPr id="31" name="Shape 31"/>
           <p:cNvSpPr txBox="1"/>
           <p:nvPr/>
         </p:nvSpPr>
@@ -17152,7 +17152,7 @@
       </p:sp>
       <p:sp>
         <p:nvSpPr>
-          <p:cNvPr id="32" name=""/>
+          <p:cNvPr id="32" name="Shape 32"/>
           <p:cNvSpPr/>
           <p:nvPr/>
         </p:nvSpPr>
@@ -17174,7 +17174,7 @@
       </p:sp>
       <p:sp>
         <p:nvSpPr>
-          <p:cNvPr id="33" name=""/>
+          <p:cNvPr id="33" name="Shape 33"/>
           <p:cNvSpPr txBox="1"/>
           <p:nvPr/>
         </p:nvSpPr>
@@ -17209,7 +17209,7 @@
       </p:sp>
       <p:sp>
         <p:nvSpPr>
-          <p:cNvPr id="34" name=""/>
+          <p:cNvPr id="34" name="Shape 34"/>
           <p:cNvSpPr txBox="1"/>
           <p:nvPr/>
         </p:nvSpPr>
@@ -17244,7 +17244,7 @@
       </p:sp>
       <p:sp>
         <p:nvSpPr>
-          <p:cNvPr id="35" name=""/>
+          <p:cNvPr id="35" name="Shape 35"/>
           <p:cNvSpPr/>
           <p:nvPr/>
         </p:nvSpPr>
@@ -17266,7 +17266,7 @@
       </p:sp>
       <p:sp>
         <p:nvSpPr>
-          <p:cNvPr id="36" name=""/>
+          <p:cNvPr id="36" name="Shape 36"/>
           <p:cNvSpPr txBox="1"/>
           <p:nvPr/>
         </p:nvSpPr>
@@ -17301,7 +17301,7 @@
       </p:sp>
       <p:sp>
         <p:nvSpPr>
-          <p:cNvPr id="37" name=""/>
+          <p:cNvPr id="37" name="Shape 37"/>
           <p:cNvSpPr txBox="1"/>
           <p:nvPr/>
         </p:nvSpPr>
@@ -17336,7 +17336,7 @@
       </p:sp>
       <p:sp>
         <p:nvSpPr>
-          <p:cNvPr id="38" name=""/>
+          <p:cNvPr id="38" name="Shape 38"/>
           <p:cNvSpPr/>
           <p:nvPr/>
         </p:nvSpPr>
@@ -17358,7 +17358,7 @@
       </p:sp>
       <p:sp>
         <p:nvSpPr>
-          <p:cNvPr id="39" name=""/>
+          <p:cNvPr id="39" name="Shape 39"/>
           <p:cNvSpPr/>
           <p:nvPr/>
         </p:nvSpPr>
@@ -17384,7 +17384,7 @@
       </p:sp>
       <p:sp>
         <p:nvSpPr>
-          <p:cNvPr id="40" name=""/>
+          <p:cNvPr id="40" name="Shape 40"/>
           <p:cNvSpPr txBox="1"/>
           <p:nvPr/>
         </p:nvSpPr>
@@ -17419,7 +17419,7 @@
       </p:sp>
       <p:sp>
         <p:nvSpPr>
-          <p:cNvPr id="41" name=""/>
+          <p:cNvPr id="41" name="Shape 41"/>
           <p:cNvSpPr txBox="1"/>
           <p:nvPr/>
         </p:nvSpPr>
@@ -17458,7 +17458,7 @@
       </p:sp>
       <p:sp>
         <p:nvSpPr>
-          <p:cNvPr id="42" name=""/>
+          <p:cNvPr id="42" name="Shape 42"/>
           <p:cNvSpPr/>
           <p:nvPr/>
         </p:nvSpPr>
@@ -17482,7 +17482,7 @@
       </p:sp>
       <p:sp>
         <p:nvSpPr>
-          <p:cNvPr id="43" name=""/>
+          <p:cNvPr id="43" name="Shape 43"/>
           <p:cNvSpPr txBox="1"/>
           <p:nvPr/>
         </p:nvSpPr>
@@ -17517,7 +17517,7 @@
       </p:sp>
       <p:sp>
         <p:nvSpPr>
-          <p:cNvPr id="44" name=""/>
+          <p:cNvPr id="44" name="Shape 44"/>
           <p:cNvSpPr txBox="1"/>
           <p:nvPr/>
         </p:nvSpPr>
@@ -17563,14 +17563,14 @@
   <p:cSld>
     <p:spTree>
       <p:nvGrpSpPr>
-        <p:cNvPr id="1" name=""/>
+        <p:cNvPr id="1" name="Shape 1"/>
         <p:cNvGrpSpPr/>
         <p:nvPr/>
       </p:nvGrpSpPr>
       <p:grpSpPr/>
       <p:sp>
         <p:nvSpPr>
-          <p:cNvPr id="2" name=""/>
+          <p:cNvPr id="2" name="Shape 2"/>
           <p:cNvSpPr/>
           <p:nvPr/>
         </p:nvSpPr>
@@ -17592,7 +17592,7 @@
       </p:sp>
       <p:sp>
         <p:nvSpPr>
-          <p:cNvPr id="3" name=""/>
+          <p:cNvPr id="3" name="Shape 3"/>
           <p:cNvSpPr/>
           <p:nvPr/>
         </p:nvSpPr>
@@ -17614,7 +17614,7 @@
       </p:sp>
       <p:sp>
         <p:nvSpPr>
-          <p:cNvPr id="4" name=""/>
+          <p:cNvPr id="4" name="Shape 4"/>
           <p:cNvSpPr txBox="1"/>
           <p:nvPr/>
         </p:nvSpPr>
@@ -17649,7 +17649,7 @@
       </p:sp>
       <p:sp>
         <p:nvSpPr>
-          <p:cNvPr id="5" name=""/>
+          <p:cNvPr id="5" name="Shape 5"/>
           <p:cNvSpPr txBox="1"/>
           <p:nvPr/>
         </p:nvSpPr>
@@ -17684,7 +17684,7 @@
       </p:sp>
       <p:pic>
         <p:nvPicPr>
-          <p:cNvPr id="6" name="" descr="logo_s.png"/>
+          <p:cNvPr id="6" name="Shape 6" descr="logo_s.png"/>
           <p:cNvPicPr>
             <a:picLocks noChangeAspect="1"/>
           </p:cNvPicPr>
@@ -17708,7 +17708,7 @@
       </p:pic>
       <p:sp>
         <p:nvSpPr>
-          <p:cNvPr id="7" name=""/>
+          <p:cNvPr id="7" name="Shape 7"/>
           <p:cNvSpPr/>
           <p:nvPr/>
         </p:nvSpPr>
@@ -17730,7 +17730,7 @@
       </p:sp>
       <p:sp>
         <p:nvSpPr>
-          <p:cNvPr id="8" name=""/>
+          <p:cNvPr id="8" name="Shape 8"/>
           <p:cNvSpPr txBox="1"/>
           <p:nvPr/>
         </p:nvSpPr>
@@ -17765,7 +17765,7 @@
       </p:sp>
       <p:sp>
         <p:nvSpPr>
-          <p:cNvPr id="9" name=""/>
+          <p:cNvPr id="9" name="Shape 9"/>
           <p:cNvSpPr txBox="1"/>
           <p:nvPr/>
         </p:nvSpPr>
@@ -17800,7 +17800,7 @@
       </p:sp>
       <p:sp>
         <p:nvSpPr>
-          <p:cNvPr id="10" name=""/>
+          <p:cNvPr id="10" name="Shape 10"/>
           <p:cNvSpPr/>
           <p:nvPr/>
         </p:nvSpPr>
@@ -17824,7 +17824,7 @@
       </p:sp>
       <p:sp>
         <p:nvSpPr>
-          <p:cNvPr id="11" name=""/>
+          <p:cNvPr id="11" name="Shape 11"/>
           <p:cNvSpPr txBox="1"/>
           <p:nvPr/>
         </p:nvSpPr>
@@ -17859,7 +17859,7 @@
       </p:sp>
       <p:sp>
         <p:nvSpPr>
-          <p:cNvPr id="12" name=""/>
+          <p:cNvPr id="12" name="Shape 12"/>
           <p:cNvSpPr txBox="1"/>
           <p:nvPr/>
         </p:nvSpPr>
@@ -17894,7 +17894,7 @@
       </p:sp>
       <p:sp>
         <p:nvSpPr>
-          <p:cNvPr id="13" name=""/>
+          <p:cNvPr id="13" name="Shape 13"/>
           <p:cNvSpPr txBox="1"/>
           <p:nvPr/>
         </p:nvSpPr>
@@ -17929,7 +17929,7 @@
       </p:sp>
       <p:sp>
         <p:nvSpPr>
-          <p:cNvPr id="14" name=""/>
+          <p:cNvPr id="14" name="Shape 14"/>
           <p:cNvSpPr/>
           <p:nvPr/>
         </p:nvSpPr>
@@ -17953,7 +17953,7 @@
       </p:sp>
       <p:sp>
         <p:nvSpPr>
-          <p:cNvPr id="15" name=""/>
+          <p:cNvPr id="15" name="Shape 15"/>
           <p:cNvSpPr txBox="1"/>
           <p:nvPr/>
         </p:nvSpPr>
@@ -17988,7 +17988,7 @@
       </p:sp>
       <p:sp>
         <p:nvSpPr>
-          <p:cNvPr id="16" name=""/>
+          <p:cNvPr id="16" name="Shape 16"/>
           <p:cNvSpPr txBox="1"/>
           <p:nvPr/>
         </p:nvSpPr>
@@ -18023,7 +18023,7 @@
       </p:sp>
       <p:sp>
         <p:nvSpPr>
-          <p:cNvPr id="17" name=""/>
+          <p:cNvPr id="17" name="Shape 17"/>
           <p:cNvSpPr txBox="1"/>
           <p:nvPr/>
         </p:nvSpPr>
@@ -18058,7 +18058,7 @@
       </p:sp>
       <p:sp>
         <p:nvSpPr>
-          <p:cNvPr id="18" name=""/>
+          <p:cNvPr id="18" name="Shape 18"/>
           <p:cNvSpPr/>
           <p:nvPr/>
         </p:nvSpPr>
@@ -18082,7 +18082,7 @@
       </p:sp>
       <p:sp>
         <p:nvSpPr>
-          <p:cNvPr id="19" name=""/>
+          <p:cNvPr id="19" name="Shape 19"/>
           <p:cNvSpPr txBox="1"/>
           <p:nvPr/>
         </p:nvSpPr>
@@ -18117,7 +18117,7 @@
       </p:sp>
       <p:sp>
         <p:nvSpPr>
-          <p:cNvPr id="20" name=""/>
+          <p:cNvPr id="20" name="Shape 20"/>
           <p:cNvSpPr txBox="1"/>
           <p:nvPr/>
         </p:nvSpPr>
@@ -18152,7 +18152,7 @@
       </p:sp>
       <p:sp>
         <p:nvSpPr>
-          <p:cNvPr id="21" name=""/>
+          <p:cNvPr id="21" name="Shape 21"/>
           <p:cNvSpPr txBox="1"/>
           <p:nvPr/>
         </p:nvSpPr>
@@ -18187,7 +18187,7 @@
       </p:sp>
       <p:sp>
         <p:nvSpPr>
-          <p:cNvPr id="22" name=""/>
+          <p:cNvPr id="22" name="Shape 22"/>
           <p:cNvSpPr/>
           <p:nvPr/>
         </p:nvSpPr>
@@ -18211,7 +18211,7 @@
       </p:sp>
       <p:sp>
         <p:nvSpPr>
-          <p:cNvPr id="23" name=""/>
+          <p:cNvPr id="23" name="Shape 23"/>
           <p:cNvSpPr txBox="1"/>
           <p:nvPr/>
         </p:nvSpPr>
@@ -18246,7 +18246,7 @@
       </p:sp>
       <p:sp>
         <p:nvSpPr>
-          <p:cNvPr id="24" name=""/>
+          <p:cNvPr id="24" name="Shape 24"/>
           <p:cNvSpPr txBox="1"/>
           <p:nvPr/>
         </p:nvSpPr>
@@ -18281,7 +18281,7 @@
       </p:sp>
       <p:sp>
         <p:nvSpPr>
-          <p:cNvPr id="25" name=""/>
+          <p:cNvPr id="25" name="Shape 25"/>
           <p:cNvSpPr txBox="1"/>
           <p:nvPr/>
         </p:nvSpPr>
@@ -18316,7 +18316,7 @@
       </p:sp>
       <p:sp>
         <p:nvSpPr>
-          <p:cNvPr id="26" name=""/>
+          <p:cNvPr id="26" name="Shape 26"/>
           <p:cNvSpPr/>
           <p:nvPr/>
         </p:nvSpPr>
@@ -18342,7 +18342,7 @@
       </p:sp>
       <p:sp>
         <p:nvSpPr>
-          <p:cNvPr id="27" name=""/>
+          <p:cNvPr id="27" name="Shape 27"/>
           <p:cNvSpPr txBox="1"/>
           <p:nvPr/>
         </p:nvSpPr>
@@ -18377,7 +18377,7 @@
       </p:sp>
       <p:sp>
         <p:nvSpPr>
-          <p:cNvPr id="28" name=""/>
+          <p:cNvPr id="28" name="Shape 28"/>
           <p:cNvSpPr txBox="1"/>
           <p:nvPr/>
         </p:nvSpPr>
@@ -18432,7 +18432,7 @@
       </p:sp>
       <p:sp>
         <p:nvSpPr>
-          <p:cNvPr id="29" name=""/>
+          <p:cNvPr id="29" name="Shape 29"/>
           <p:cNvSpPr/>
           <p:nvPr/>
         </p:nvSpPr>
@@ -18458,7 +18458,7 @@
       </p:sp>
       <p:sp>
         <p:nvSpPr>
-          <p:cNvPr id="30" name=""/>
+          <p:cNvPr id="30" name="Shape 30"/>
           <p:cNvSpPr txBox="1"/>
           <p:nvPr/>
         </p:nvSpPr>
@@ -18493,7 +18493,7 @@
       </p:sp>
       <p:sp>
         <p:nvSpPr>
-          <p:cNvPr id="31" name=""/>
+          <p:cNvPr id="31" name="Shape 31"/>
           <p:cNvSpPr txBox="1"/>
           <p:nvPr/>
         </p:nvSpPr>
@@ -18548,7 +18548,7 @@
       </p:sp>
       <p:sp>
         <p:nvSpPr>
-          <p:cNvPr id="32" name=""/>
+          <p:cNvPr id="32" name="Shape 32"/>
           <p:cNvSpPr/>
           <p:nvPr/>
         </p:nvSpPr>
@@ -18574,7 +18574,7 @@
       </p:sp>
       <p:sp>
         <p:nvSpPr>
-          <p:cNvPr id="33" name=""/>
+          <p:cNvPr id="33" name="Shape 33"/>
           <p:cNvSpPr txBox="1"/>
           <p:nvPr/>
         </p:nvSpPr>
@@ -18609,7 +18609,7 @@
       </p:sp>
       <p:sp>
         <p:nvSpPr>
-          <p:cNvPr id="34" name=""/>
+          <p:cNvPr id="34" name="Shape 34"/>
           <p:cNvSpPr txBox="1"/>
           <p:nvPr/>
         </p:nvSpPr>
@@ -18691,14 +18691,14 @@
   <p:cSld>
     <p:spTree>
       <p:nvGrpSpPr>
-        <p:cNvPr id="1" name=""/>
+        <p:cNvPr id="1" name="Shape 1"/>
         <p:cNvGrpSpPr/>
         <p:nvPr/>
       </p:nvGrpSpPr>
       <p:grpSpPr/>
       <p:sp>
         <p:nvSpPr>
-          <p:cNvPr id="2" name=""/>
+          <p:cNvPr id="2" name="Shape 2"/>
           <p:cNvSpPr/>
           <p:nvPr/>
         </p:nvSpPr>
@@ -18720,7 +18720,7 @@
       </p:sp>
       <p:sp>
         <p:nvSpPr>
-          <p:cNvPr id="3" name=""/>
+          <p:cNvPr id="3" name="Shape 3"/>
           <p:cNvSpPr/>
           <p:nvPr/>
         </p:nvSpPr>
@@ -18742,7 +18742,7 @@
       </p:sp>
       <p:sp>
         <p:nvSpPr>
-          <p:cNvPr id="4" name=""/>
+          <p:cNvPr id="4" name="Shape 4"/>
           <p:cNvSpPr txBox="1"/>
           <p:nvPr/>
         </p:nvSpPr>
@@ -18777,7 +18777,7 @@
       </p:sp>
       <p:sp>
         <p:nvSpPr>
-          <p:cNvPr id="5" name=""/>
+          <p:cNvPr id="5" name="Shape 5"/>
           <p:cNvSpPr txBox="1"/>
           <p:nvPr/>
         </p:nvSpPr>
@@ -18812,7 +18812,7 @@
       </p:sp>
       <p:pic>
         <p:nvPicPr>
-          <p:cNvPr id="6" name="" descr="logo_s.png"/>
+          <p:cNvPr id="6" name="Shape 6" descr="logo_s.png"/>
           <p:cNvPicPr>
             <a:picLocks noChangeAspect="1"/>
           </p:cNvPicPr>
@@ -18836,7 +18836,7 @@
       </p:pic>
       <p:sp>
         <p:nvSpPr>
-          <p:cNvPr id="7" name=""/>
+          <p:cNvPr id="7" name="Shape 7"/>
           <p:cNvSpPr/>
           <p:nvPr/>
         </p:nvSpPr>
@@ -18858,7 +18858,7 @@
       </p:sp>
       <p:sp>
         <p:nvSpPr>
-          <p:cNvPr id="8" name=""/>
+          <p:cNvPr id="8" name="Shape 8"/>
           <p:cNvSpPr txBox="1"/>
           <p:nvPr/>
         </p:nvSpPr>
@@ -18893,7 +18893,7 @@
       </p:sp>
       <p:sp>
         <p:nvSpPr>
-          <p:cNvPr id="9" name=""/>
+          <p:cNvPr id="9" name="Shape 9"/>
           <p:cNvSpPr txBox="1"/>
           <p:nvPr/>
         </p:nvSpPr>
@@ -18928,7 +18928,7 @@
       </p:sp>
       <p:graphicFrame>
         <p:nvGraphicFramePr>
-          <p:cNvPr id="10" name=""/>
+          <p:cNvPr id="10" name="Shape 10"/>
           <p:cNvGraphicFramePr>
             <a:graphicFrameLocks noGrp="1"/>
           </p:cNvGraphicFramePr>
@@ -20218,7 +20218,7 @@
       </p:graphicFrame>
       <p:sp>
         <p:nvSpPr>
-          <p:cNvPr id="11" name=""/>
+          <p:cNvPr id="11" name="Shape 11"/>
           <p:cNvSpPr/>
           <p:nvPr/>
         </p:nvSpPr>
@@ -20244,7 +20244,7 @@
       </p:sp>
       <p:sp>
         <p:nvSpPr>
-          <p:cNvPr id="12" name=""/>
+          <p:cNvPr id="12" name="Shape 12"/>
           <p:cNvSpPr txBox="1"/>
           <p:nvPr/>
         </p:nvSpPr>
@@ -20279,7 +20279,7 @@
       </p:sp>
       <p:sp>
         <p:nvSpPr>
-          <p:cNvPr id="13" name=""/>
+          <p:cNvPr id="13" name="Shape 13"/>
           <p:cNvSpPr txBox="1"/>
           <p:nvPr/>
         </p:nvSpPr>
@@ -20350,7 +20350,7 @@
       </p:sp>
       <p:sp>
         <p:nvSpPr>
-          <p:cNvPr id="14" name=""/>
+          <p:cNvPr id="14" name="Shape 14"/>
           <p:cNvSpPr/>
           <p:nvPr/>
         </p:nvSpPr>
@@ -20376,7 +20376,7 @@
       </p:sp>
       <p:sp>
         <p:nvSpPr>
-          <p:cNvPr id="15" name=""/>
+          <p:cNvPr id="15" name="Shape 15"/>
           <p:cNvSpPr txBox="1"/>
           <p:nvPr/>
         </p:nvSpPr>
@@ -20411,7 +20411,7 @@
       </p:sp>
       <p:sp>
         <p:nvSpPr>
-          <p:cNvPr id="16" name=""/>
+          <p:cNvPr id="16" name="Shape 16"/>
           <p:cNvSpPr txBox="1"/>
           <p:nvPr/>
         </p:nvSpPr>
@@ -20477,14 +20477,14 @@
   <p:cSld>
     <p:spTree>
       <p:nvGrpSpPr>
-        <p:cNvPr id="1" name=""/>
+        <p:cNvPr id="1" name="Shape 1"/>
         <p:cNvGrpSpPr/>
         <p:nvPr/>
       </p:nvGrpSpPr>
       <p:grpSpPr/>
       <p:sp>
         <p:nvSpPr>
-          <p:cNvPr id="2" name=""/>
+          <p:cNvPr id="2" name="Shape 2"/>
           <p:cNvSpPr/>
           <p:nvPr/>
         </p:nvSpPr>
@@ -20506,7 +20506,7 @@
       </p:sp>
       <p:sp>
         <p:nvSpPr>
-          <p:cNvPr id="3" name=""/>
+          <p:cNvPr id="3" name="Shape 3"/>
           <p:cNvSpPr/>
           <p:nvPr/>
         </p:nvSpPr>
@@ -20528,7 +20528,7 @@
       </p:sp>
       <p:sp>
         <p:nvSpPr>
-          <p:cNvPr id="4" name=""/>
+          <p:cNvPr id="4" name="Shape 4"/>
           <p:cNvSpPr txBox="1"/>
           <p:nvPr/>
         </p:nvSpPr>
@@ -20563,7 +20563,7 @@
       </p:sp>
       <p:sp>
         <p:nvSpPr>
-          <p:cNvPr id="5" name=""/>
+          <p:cNvPr id="5" name="Shape 5"/>
           <p:cNvSpPr txBox="1"/>
           <p:nvPr/>
         </p:nvSpPr>
@@ -20598,7 +20598,7 @@
       </p:sp>
       <p:pic>
         <p:nvPicPr>
-          <p:cNvPr id="6" name="" descr="logo_s.png"/>
+          <p:cNvPr id="6" name="Shape 6" descr="logo_s.png"/>
           <p:cNvPicPr>
             <a:picLocks noChangeAspect="1"/>
           </p:cNvPicPr>
@@ -20622,7 +20622,7 @@
       </p:pic>
       <p:sp>
         <p:nvSpPr>
-          <p:cNvPr id="7" name=""/>
+          <p:cNvPr id="7" name="Shape 7"/>
           <p:cNvSpPr/>
           <p:nvPr/>
         </p:nvSpPr>
@@ -20644,7 +20644,7 @@
       </p:sp>
       <p:sp>
         <p:nvSpPr>
-          <p:cNvPr id="8" name=""/>
+          <p:cNvPr id="8" name="Shape 8"/>
           <p:cNvSpPr txBox="1"/>
           <p:nvPr/>
         </p:nvSpPr>
@@ -20679,7 +20679,7 @@
       </p:sp>
       <p:sp>
         <p:nvSpPr>
-          <p:cNvPr id="9" name=""/>
+          <p:cNvPr id="9" name="Shape 9"/>
           <p:cNvSpPr txBox="1"/>
           <p:nvPr/>
         </p:nvSpPr>
@@ -20714,7 +20714,7 @@
       </p:sp>
       <p:sp>
         <p:nvSpPr>
-          <p:cNvPr id="10" name=""/>
+          <p:cNvPr id="10" name="Shape 10"/>
           <p:cNvSpPr/>
           <p:nvPr/>
         </p:nvSpPr>
@@ -20738,7 +20738,7 @@
       </p:sp>
       <p:sp>
         <p:nvSpPr>
-          <p:cNvPr id="11" name=""/>
+          <p:cNvPr id="11" name="Shape 11"/>
           <p:cNvSpPr txBox="1"/>
           <p:nvPr/>
         </p:nvSpPr>
@@ -20773,7 +20773,7 @@
       </p:sp>
       <p:sp>
         <p:nvSpPr>
-          <p:cNvPr id="12" name=""/>
+          <p:cNvPr id="12" name="Shape 12"/>
           <p:cNvSpPr txBox="1"/>
           <p:nvPr/>
         </p:nvSpPr>
@@ -20808,7 +20808,7 @@
       </p:sp>
       <p:sp>
         <p:nvSpPr>
-          <p:cNvPr id="13" name=""/>
+          <p:cNvPr id="13" name="Shape 13"/>
           <p:cNvSpPr txBox="1"/>
           <p:nvPr/>
         </p:nvSpPr>
@@ -20843,7 +20843,7 @@
       </p:sp>
       <p:sp>
         <p:nvSpPr>
-          <p:cNvPr id="14" name=""/>
+          <p:cNvPr id="14" name="Shape 14"/>
           <p:cNvSpPr/>
           <p:nvPr/>
         </p:nvSpPr>
@@ -20867,7 +20867,7 @@
       </p:sp>
       <p:sp>
         <p:nvSpPr>
-          <p:cNvPr id="15" name=""/>
+          <p:cNvPr id="15" name="Shape 15"/>
           <p:cNvSpPr txBox="1"/>
           <p:nvPr/>
         </p:nvSpPr>
@@ -20902,7 +20902,7 @@
       </p:sp>
       <p:sp>
         <p:nvSpPr>
-          <p:cNvPr id="16" name=""/>
+          <p:cNvPr id="16" name="Shape 16"/>
           <p:cNvSpPr txBox="1"/>
           <p:nvPr/>
         </p:nvSpPr>
@@ -20937,7 +20937,7 @@
       </p:sp>
       <p:sp>
         <p:nvSpPr>
-          <p:cNvPr id="17" name=""/>
+          <p:cNvPr id="17" name="Shape 17"/>
           <p:cNvSpPr txBox="1"/>
           <p:nvPr/>
         </p:nvSpPr>
@@ -20972,7 +20972,7 @@
       </p:sp>
       <p:sp>
         <p:nvSpPr>
-          <p:cNvPr id="18" name=""/>
+          <p:cNvPr id="18" name="Shape 18"/>
           <p:cNvSpPr/>
           <p:nvPr/>
         </p:nvSpPr>
@@ -20996,7 +20996,7 @@
       </p:sp>
       <p:sp>
         <p:nvSpPr>
-          <p:cNvPr id="19" name=""/>
+          <p:cNvPr id="19" name="Shape 19"/>
           <p:cNvSpPr txBox="1"/>
           <p:nvPr/>
         </p:nvSpPr>
@@ -21031,7 +21031,7 @@
       </p:sp>
       <p:sp>
         <p:nvSpPr>
-          <p:cNvPr id="20" name=""/>
+          <p:cNvPr id="20" name="Shape 20"/>
           <p:cNvSpPr txBox="1"/>
           <p:nvPr/>
         </p:nvSpPr>
@@ -21066,7 +21066,7 @@
       </p:sp>
       <p:sp>
         <p:nvSpPr>
-          <p:cNvPr id="21" name=""/>
+          <p:cNvPr id="21" name="Shape 21"/>
           <p:cNvSpPr txBox="1"/>
           <p:nvPr/>
         </p:nvSpPr>
@@ -21101,7 +21101,7 @@
       </p:sp>
       <p:sp>
         <p:nvSpPr>
-          <p:cNvPr id="22" name=""/>
+          <p:cNvPr id="22" name="Shape 22"/>
           <p:cNvSpPr/>
           <p:nvPr/>
         </p:nvSpPr>
@@ -21125,7 +21125,7 @@
       </p:sp>
       <p:sp>
         <p:nvSpPr>
-          <p:cNvPr id="23" name=""/>
+          <p:cNvPr id="23" name="Shape 23"/>
           <p:cNvSpPr txBox="1"/>
           <p:nvPr/>
         </p:nvSpPr>
@@ -21160,7 +21160,7 @@
       </p:sp>
       <p:sp>
         <p:nvSpPr>
-          <p:cNvPr id="24" name=""/>
+          <p:cNvPr id="24" name="Shape 24"/>
           <p:cNvSpPr txBox="1"/>
           <p:nvPr/>
         </p:nvSpPr>
@@ -21195,7 +21195,7 @@
       </p:sp>
       <p:sp>
         <p:nvSpPr>
-          <p:cNvPr id="25" name=""/>
+          <p:cNvPr id="25" name="Shape 25"/>
           <p:cNvSpPr txBox="1"/>
           <p:nvPr/>
         </p:nvSpPr>
@@ -21230,7 +21230,7 @@
       </p:sp>
       <p:graphicFrame>
         <p:nvGraphicFramePr>
-          <p:cNvPr id="26" name=""/>
+          <p:cNvPr id="26" name="Shape 26"/>
           <p:cNvGraphicFramePr>
             <a:graphicFrameLocks noGrp="1"/>
           </p:cNvGraphicFramePr>
@@ -22378,7 +22378,7 @@
       </p:graphicFrame>
       <p:sp>
         <p:nvSpPr>
-          <p:cNvPr id="27" name=""/>
+          <p:cNvPr id="27" name="Shape 27"/>
           <p:cNvSpPr/>
           <p:nvPr/>
         </p:nvSpPr>
@@ -22404,7 +22404,7 @@
       </p:sp>
       <p:sp>
         <p:nvSpPr>
-          <p:cNvPr id="28" name=""/>
+          <p:cNvPr id="28" name="Shape 28"/>
           <p:cNvSpPr txBox="1"/>
           <p:nvPr/>
         </p:nvSpPr>
@@ -22439,7 +22439,7 @@
       </p:sp>
       <p:sp>
         <p:nvSpPr>
-          <p:cNvPr id="29" name=""/>
+          <p:cNvPr id="29" name="Shape 29"/>
           <p:cNvSpPr txBox="1"/>
           <p:nvPr/>
         </p:nvSpPr>
@@ -22537,14 +22537,14 @@
   <p:cSld>
     <p:spTree>
       <p:nvGrpSpPr>
-        <p:cNvPr id="1" name=""/>
+        <p:cNvPr id="1" name="Shape 1"/>
         <p:cNvGrpSpPr/>
         <p:nvPr/>
       </p:nvGrpSpPr>
       <p:grpSpPr/>
       <p:sp>
         <p:nvSpPr>
-          <p:cNvPr id="2" name=""/>
+          <p:cNvPr id="2" name="Shape 2"/>
           <p:cNvSpPr/>
           <p:nvPr/>
         </p:nvSpPr>
@@ -22566,7 +22566,7 @@
       </p:sp>
       <p:sp>
         <p:nvSpPr>
-          <p:cNvPr id="3" name=""/>
+          <p:cNvPr id="3" name="Shape 3"/>
           <p:cNvSpPr/>
           <p:nvPr/>
         </p:nvSpPr>
@@ -22588,7 +22588,7 @@
       </p:sp>
       <p:sp>
         <p:nvSpPr>
-          <p:cNvPr id="4" name=""/>
+          <p:cNvPr id="4" name="Shape 4"/>
           <p:cNvSpPr txBox="1"/>
           <p:nvPr/>
         </p:nvSpPr>
@@ -22623,7 +22623,7 @@
       </p:sp>
       <p:sp>
         <p:nvSpPr>
-          <p:cNvPr id="5" name=""/>
+          <p:cNvPr id="5" name="Shape 5"/>
           <p:cNvSpPr txBox="1"/>
           <p:nvPr/>
         </p:nvSpPr>
@@ -22658,7 +22658,7 @@
       </p:sp>
       <p:pic>
         <p:nvPicPr>
-          <p:cNvPr id="6" name="" descr="logo_s.png"/>
+          <p:cNvPr id="6" name="Shape 6" descr="logo_s.png"/>
           <p:cNvPicPr>
             <a:picLocks noChangeAspect="1"/>
           </p:cNvPicPr>
@@ -22682,7 +22682,7 @@
       </p:pic>
       <p:sp>
         <p:nvSpPr>
-          <p:cNvPr id="7" name=""/>
+          <p:cNvPr id="7" name="Shape 7"/>
           <p:cNvSpPr/>
           <p:nvPr/>
         </p:nvSpPr>
@@ -22704,7 +22704,7 @@
       </p:sp>
       <p:sp>
         <p:nvSpPr>
-          <p:cNvPr id="8" name=""/>
+          <p:cNvPr id="8" name="Shape 8"/>
           <p:cNvSpPr txBox="1"/>
           <p:nvPr/>
         </p:nvSpPr>
@@ -22739,7 +22739,7 @@
       </p:sp>
       <p:sp>
         <p:nvSpPr>
-          <p:cNvPr id="9" name=""/>
+          <p:cNvPr id="9" name="Shape 9"/>
           <p:cNvSpPr txBox="1"/>
           <p:nvPr/>
         </p:nvSpPr>
@@ -22774,7 +22774,7 @@
       </p:sp>
       <p:sp>
         <p:nvSpPr>
-          <p:cNvPr id="10" name=""/>
+          <p:cNvPr id="10" name="Shape 10"/>
           <p:cNvSpPr/>
           <p:nvPr/>
         </p:nvSpPr>
@@ -22798,7 +22798,7 @@
       </p:sp>
       <p:sp>
         <p:nvSpPr>
-          <p:cNvPr id="11" name=""/>
+          <p:cNvPr id="11" name="Shape 11"/>
           <p:cNvSpPr txBox="1"/>
           <p:nvPr/>
         </p:nvSpPr>
@@ -22833,7 +22833,7 @@
       </p:sp>
       <p:sp>
         <p:nvSpPr>
-          <p:cNvPr id="12" name=""/>
+          <p:cNvPr id="12" name="Shape 12"/>
           <p:cNvSpPr txBox="1"/>
           <p:nvPr/>
         </p:nvSpPr>
@@ -22877,7 +22877,7 @@
       </p:sp>
       <p:sp>
         <p:nvSpPr>
-          <p:cNvPr id="13" name=""/>
+          <p:cNvPr id="13" name="Shape 13"/>
           <p:cNvSpPr/>
           <p:nvPr/>
         </p:nvSpPr>
@@ -22901,7 +22901,7 @@
       </p:sp>
       <p:sp>
         <p:nvSpPr>
-          <p:cNvPr id="14" name=""/>
+          <p:cNvPr id="14" name="Shape 14"/>
           <p:cNvSpPr txBox="1"/>
           <p:nvPr/>
         </p:nvSpPr>
@@ -22936,7 +22936,7 @@
       </p:sp>
       <p:sp>
         <p:nvSpPr>
-          <p:cNvPr id="15" name=""/>
+          <p:cNvPr id="15" name="Shape 15"/>
           <p:cNvSpPr txBox="1"/>
           <p:nvPr/>
         </p:nvSpPr>
@@ -22980,7 +22980,7 @@
       </p:sp>
       <p:sp>
         <p:nvSpPr>
-          <p:cNvPr id="16" name=""/>
+          <p:cNvPr id="16" name="Shape 16"/>
           <p:cNvSpPr/>
           <p:nvPr/>
         </p:nvSpPr>
@@ -23004,7 +23004,7 @@
       </p:sp>
       <p:sp>
         <p:nvSpPr>
-          <p:cNvPr id="17" name=""/>
+          <p:cNvPr id="17" name="Shape 17"/>
           <p:cNvSpPr txBox="1"/>
           <p:nvPr/>
         </p:nvSpPr>
@@ -23039,7 +23039,7 @@
       </p:sp>
       <p:sp>
         <p:nvSpPr>
-          <p:cNvPr id="18" name=""/>
+          <p:cNvPr id="18" name="Shape 18"/>
           <p:cNvSpPr txBox="1"/>
           <p:nvPr/>
         </p:nvSpPr>
@@ -23083,7 +23083,7 @@
       </p:sp>
       <p:sp>
         <p:nvSpPr>
-          <p:cNvPr id="19" name=""/>
+          <p:cNvPr id="19" name="Shape 19"/>
           <p:cNvSpPr/>
           <p:nvPr/>
         </p:nvSpPr>
@@ -23107,7 +23107,7 @@
       </p:sp>
       <p:sp>
         <p:nvSpPr>
-          <p:cNvPr id="20" name=""/>
+          <p:cNvPr id="20" name="Shape 20"/>
           <p:cNvSpPr txBox="1"/>
           <p:nvPr/>
         </p:nvSpPr>
@@ -23142,7 +23142,7 @@
       </p:sp>
       <p:sp>
         <p:nvSpPr>
-          <p:cNvPr id="21" name=""/>
+          <p:cNvPr id="21" name="Shape 21"/>
           <p:cNvSpPr txBox="1"/>
           <p:nvPr/>
         </p:nvSpPr>
@@ -23186,7 +23186,7 @@
       </p:sp>
       <p:sp>
         <p:nvSpPr>
-          <p:cNvPr id="22" name=""/>
+          <p:cNvPr id="22" name="Shape 22"/>
           <p:cNvSpPr/>
           <p:nvPr/>
         </p:nvSpPr>
@@ -23210,7 +23210,7 @@
       </p:sp>
       <p:sp>
         <p:nvSpPr>
-          <p:cNvPr id="23" name=""/>
+          <p:cNvPr id="23" name="Shape 23"/>
           <p:cNvSpPr txBox="1"/>
           <p:nvPr/>
         </p:nvSpPr>
@@ -23245,7 +23245,7 @@
       </p:sp>
       <p:sp>
         <p:nvSpPr>
-          <p:cNvPr id="24" name=""/>
+          <p:cNvPr id="24" name="Shape 24"/>
           <p:cNvSpPr txBox="1"/>
           <p:nvPr/>
         </p:nvSpPr>
@@ -23289,7 +23289,7 @@
       </p:sp>
       <p:sp>
         <p:nvSpPr>
-          <p:cNvPr id="25" name=""/>
+          <p:cNvPr id="25" name="Shape 25"/>
           <p:cNvSpPr/>
           <p:nvPr/>
         </p:nvSpPr>
@@ -23313,7 +23313,7 @@
       </p:sp>
       <p:sp>
         <p:nvSpPr>
-          <p:cNvPr id="26" name=""/>
+          <p:cNvPr id="26" name="Shape 26"/>
           <p:cNvSpPr txBox="1"/>
           <p:nvPr/>
         </p:nvSpPr>
@@ -23348,7 +23348,7 @@
       </p:sp>
       <p:sp>
         <p:nvSpPr>
-          <p:cNvPr id="27" name=""/>
+          <p:cNvPr id="27" name="Shape 27"/>
           <p:cNvSpPr txBox="1"/>
           <p:nvPr/>
         </p:nvSpPr>
@@ -23392,7 +23392,7 @@
       </p:sp>
       <p:graphicFrame>
         <p:nvGraphicFramePr>
-          <p:cNvPr id="28" name=""/>
+          <p:cNvPr id="28" name="Shape 28"/>
           <p:cNvGraphicFramePr>
             <a:graphicFrameLocks noGrp="1"/>
           </p:cNvGraphicFramePr>
@@ -25317,14 +25317,14 @@
   <p:cSld>
     <p:spTree>
       <p:nvGrpSpPr>
-        <p:cNvPr id="1" name=""/>
+        <p:cNvPr id="1" name="Shape 1"/>
         <p:cNvGrpSpPr/>
         <p:nvPr/>
       </p:nvGrpSpPr>
       <p:grpSpPr/>
       <p:sp>
         <p:nvSpPr>
-          <p:cNvPr id="2" name=""/>
+          <p:cNvPr id="2" name="Shape 2"/>
           <p:cNvSpPr/>
           <p:nvPr/>
         </p:nvSpPr>
@@ -25346,7 +25346,7 @@
       </p:sp>
       <p:sp>
         <p:nvSpPr>
-          <p:cNvPr id="3" name=""/>
+          <p:cNvPr id="3" name="Shape 3"/>
           <p:cNvSpPr/>
           <p:nvPr/>
         </p:nvSpPr>
@@ -25368,7 +25368,7 @@
       </p:sp>
       <p:sp>
         <p:nvSpPr>
-          <p:cNvPr id="4" name=""/>
+          <p:cNvPr id="4" name="Shape 4"/>
           <p:cNvSpPr txBox="1"/>
           <p:nvPr/>
         </p:nvSpPr>
@@ -25403,7 +25403,7 @@
       </p:sp>
       <p:sp>
         <p:nvSpPr>
-          <p:cNvPr id="5" name=""/>
+          <p:cNvPr id="5" name="Shape 5"/>
           <p:cNvSpPr txBox="1"/>
           <p:nvPr/>
         </p:nvSpPr>
@@ -25438,7 +25438,7 @@
       </p:sp>
       <p:pic>
         <p:nvPicPr>
-          <p:cNvPr id="6" name="" descr="logo_s.png"/>
+          <p:cNvPr id="6" name="Shape 6" descr="logo_s.png"/>
           <p:cNvPicPr>
             <a:picLocks noChangeAspect="1"/>
           </p:cNvPicPr>
@@ -25462,7 +25462,7 @@
       </p:pic>
       <p:sp>
         <p:nvSpPr>
-          <p:cNvPr id="7" name=""/>
+          <p:cNvPr id="7" name="Shape 7"/>
           <p:cNvSpPr/>
           <p:nvPr/>
         </p:nvSpPr>
@@ -25484,7 +25484,7 @@
       </p:sp>
       <p:sp>
         <p:nvSpPr>
-          <p:cNvPr id="8" name=""/>
+          <p:cNvPr id="8" name="Shape 8"/>
           <p:cNvSpPr txBox="1"/>
           <p:nvPr/>
         </p:nvSpPr>
@@ -25519,7 +25519,7 @@
       </p:sp>
       <p:sp>
         <p:nvSpPr>
-          <p:cNvPr id="9" name=""/>
+          <p:cNvPr id="9" name="Shape 9"/>
           <p:cNvSpPr txBox="1"/>
           <p:nvPr/>
         </p:nvSpPr>
@@ -25554,7 +25554,7 @@
       </p:sp>
       <p:graphicFrame>
         <p:nvGraphicFramePr>
-          <p:cNvPr id="10" name=""/>
+          <p:cNvPr id="10" name="Shape 10"/>
           <p:cNvGraphicFramePr>
             <a:graphicFrameLocks noGrp="1"/>
           </p:cNvGraphicFramePr>
@@ -26237,7 +26237,7 @@
       </p:graphicFrame>
       <p:sp>
         <p:nvSpPr>
-          <p:cNvPr id="11" name=""/>
+          <p:cNvPr id="11" name="Shape 11"/>
           <p:cNvSpPr txBox="1"/>
           <p:nvPr/>
         </p:nvSpPr>

</xml_diff>